<commit_message>
FreeP Wave133 admit relationship1 SmartArt cache
</commit_message>
<xml_diff>
--- a/tools/FreeP.RenderCompare/corpus/15-smartart-grouped-list.pptx
+++ b/tools/FreeP.RenderCompare/corpus/15-smartart-grouped-list.pptx
@@ -11,6 +11,7 @@
     <p:sldId id="259" r:id="rIdSlide4"/>
     <p:sldId id="260" r:id="rIdSlide5"/>
     <p:sldId id="261" r:id="rIdSlide6"/>
+    <p:sldId id="262" r:id="rIdSlide7"/>
   </p:sldIdLst>
   <p:sldSz cx="9144000" cy="6858000"/>
   <p:notesSz cx="6858000" cy="9144000"/>
@@ -46,6 +47,10 @@
 <dgm:colorsDef xmlns:dgm="http://schemas.openxmlformats.org/drawingml/2006/diagram"/>
 </file>
 
+<file path=ppt/diagrams/colors7.xml><?xml version="1.0" encoding="utf-8"?>
+<dgm:colorsDef xmlns:dgm="http://schemas.openxmlformats.org/drawingml/2006/diagram"/>
+</file>
+
 <file path=ppt/diagrams/data1.xml><?xml version="1.0" encoding="utf-8"?>
 <dgm:dataModel xmlns:dgm="http://schemas.openxmlformats.org/drawingml/2006/diagram" xmlns:a="http://schemas.openxmlformats.org/drawingml/2006/main">
   <dgm:ptLst>
@@ -392,6 +397,44 @@
 </dgm:dataModel>
 </file>
 
+<file path=ppt/diagrams/data7.xml><?xml version="1.0" encoding="utf-8"?>
+<dgm:dataModel xmlns:dgm="http://schemas.openxmlformats.org/drawingml/2006/diagram" xmlns:a="http://schemas.openxmlformats.org/drawingml/2006/main">
+  <dgm:ptLst>
+    <dgm:pt modelId="rel1" type="node">
+      <dgm:t>
+        <a:p>
+          <a:r>
+            <a:rPr lang="en-US"/>
+            <a:t>Audience</a:t>
+          </a:r>
+        </a:p>
+      </dgm:t>
+    </dgm:pt>
+    <dgm:pt modelId="rel2" type="node">
+      <dgm:t>
+        <a:p>
+          <a:r>
+            <a:rPr lang="en-US"/>
+            <a:t>Need</a:t>
+          </a:r>
+        </a:p>
+      </dgm:t>
+    </dgm:pt>
+    <dgm:pt modelId="rel3" type="node">
+      <dgm:t>
+        <a:p>
+          <a:r>
+            <a:rPr lang="en-US"/>
+            <a:t>Offer</a:t>
+          </a:r>
+        </a:p>
+      </dgm:t>
+    </dgm:pt>
+  </dgm:ptLst>
+  <dgm:cxnLst/>
+</dgm:dataModel>
+</file>
+
 <file path=ppt/diagrams/drawing1.xml><?xml version="1.0" encoding="utf-8"?>
 <dsp:drawing xmlns:dsp="http://schemas.microsoft.com/office/drawing/2008/diagram">
   <dsp:spTree/>
@@ -886,6 +929,103 @@
 </dsp:drawing>
 </file>
 
+<file path=ppt/diagrams/drawing7.xml><?xml version="1.0" encoding="utf-8"?>
+<dsp:drawing xmlns:dsp="http://schemas.microsoft.com/office/drawing/2008/diagram" xmlns:a="http://schemas.openxmlformats.org/drawingml/2006/main">
+  <dsp:spTree>
+    <dsp:sp>
+      <dsp:nvSpPr>
+        <dsp:cNvPr id="70" name="Relationship1 node 1"/>
+        <dsp:cNvSpPr/>
+        <dsp:nvPr/>
+      </dsp:nvSpPr>
+      <dsp:spPr>
+        <a:xfrm>
+          <a:off x="1522800" y="1672400"/>
+          <a:ext cx="2400000" cy="2400000"/>
+        </a:xfrm>
+        <a:prstGeom prst="ellipse">
+          <a:avLst/>
+        </a:prstGeom>
+        <a:solidFill>
+          <a:srgbClr val="4472C4"/>
+        </a:solidFill>
+        <a:ln/>
+      </dsp:spPr>
+      <dsp:txBody>
+        <a:bodyPr/>
+        <a:lstStyle/>
+        <a:p>
+          <a:r>
+            <a:rPr lang="en-US"/>
+            <a:t>Audience</a:t>
+          </a:r>
+        </a:p>
+      </dsp:txBody>
+    </dsp:sp>
+    <dsp:sp>
+      <dsp:nvSpPr>
+        <dsp:cNvPr id="71" name="Relationship1 node 2"/>
+        <dsp:cNvSpPr/>
+        <dsp:nvPr/>
+      </dsp:nvSpPr>
+      <dsp:spPr>
+        <a:xfrm>
+          <a:off x="2914800" y="1672400"/>
+          <a:ext cx="2400000" cy="2400000"/>
+        </a:xfrm>
+        <a:prstGeom prst="ellipse">
+          <a:avLst/>
+        </a:prstGeom>
+        <a:solidFill>
+          <a:srgbClr val="4472C4"/>
+        </a:solidFill>
+        <a:ln/>
+      </dsp:spPr>
+      <dsp:txBody>
+        <a:bodyPr/>
+        <a:lstStyle/>
+        <a:p>
+          <a:r>
+            <a:rPr lang="en-US"/>
+            <a:t>Need</a:t>
+          </a:r>
+        </a:p>
+      </dsp:txBody>
+    </dsp:sp>
+    <dsp:sp>
+      <dsp:nvSpPr>
+        <dsp:cNvPr id="72" name="Relationship1 node 3"/>
+        <dsp:cNvSpPr/>
+        <dsp:nvPr/>
+      </dsp:nvSpPr>
+      <dsp:spPr>
+        <a:xfrm>
+          <a:off x="4306800" y="1672400"/>
+          <a:ext cx="2400000" cy="2400000"/>
+        </a:xfrm>
+        <a:prstGeom prst="ellipse">
+          <a:avLst/>
+        </a:prstGeom>
+        <a:solidFill>
+          <a:srgbClr val="4472C4"/>
+        </a:solidFill>
+        <a:ln/>
+      </dsp:spPr>
+      <dsp:txBody>
+        <a:bodyPr/>
+        <a:lstStyle/>
+        <a:p>
+          <a:r>
+            <a:rPr lang="en-US"/>
+            <a:t>Offer</a:t>
+          </a:r>
+        </a:p>
+      </dsp:txBody>
+    </dsp:sp>
+  </dsp:spTree>
+</dsp:drawing>
+</file>
+
 <file path=ppt/diagrams/layout1.xml><?xml version="1.0" encoding="utf-8"?>
 <dgm:layoutDef xmlns:dgm="http://schemas.openxmlformats.org/drawingml/2006/diagram" uniqueId="urn:microsoft.com/office/officeart/2005/8/layout/process1"/>
 </file>
@@ -910,6 +1050,10 @@
 <dgm:layoutDef xmlns:dgm="http://schemas.openxmlformats.org/drawingml/2006/diagram" uniqueId="urn:microsoft.com/office/officeart/2005/8/layout/groupedList"/>
 </file>
 
+<file path=ppt/diagrams/layout7.xml><?xml version="1.0" encoding="utf-8"?>
+<dgm:layoutDef xmlns:dgm="http://schemas.openxmlformats.org/drawingml/2006/diagram" uniqueId="urn:microsoft.com/office/officeart/2005/8/layout/relationship1"/>
+</file>
+
 <file path=ppt/diagrams/quickStyle1.xml><?xml version="1.0" encoding="utf-8"?>
 <dgm:styleDef xmlns:dgm="http://schemas.openxmlformats.org/drawingml/2006/diagram"/>
 </file>
@@ -931,6 +1075,10 @@
 </file>
 
 <file path=ppt/diagrams/quickStyle6.xml><?xml version="1.0" encoding="utf-8"?>
+<dgm:styleDef xmlns:dgm="http://schemas.openxmlformats.org/drawingml/2006/diagram"/>
+</file>
+
+<file path=ppt/diagrams/quickStyle7.xml><?xml version="1.0" encoding="utf-8"?>
 <dgm:styleDef xmlns:dgm="http://schemas.openxmlformats.org/drawingml/2006/diagram"/>
 </file>
 
@@ -1351,6 +1499,71 @@
       <p:graphicFrame>
         <p:nvGraphicFramePr>
           <p:cNvPr id="3" name="SmartArt 6"/>
+          <p:cNvGraphicFramePr/>
+          <p:nvPr/>
+        </p:nvGraphicFramePr>
+        <p:xfrm>
+          <a:off x="457200" y="680000"/>
+          <a:ext cx="8229600" cy="5744800"/>
+        </p:xfrm>
+        <a:graphic>
+          <a:graphicData uri="http://schemas.openxmlformats.org/drawingml/2006/diagram">
+            <dgm:relIds xmlns:dgm="http://schemas.openxmlformats.org/drawingml/2006/diagram" xmlns:r="http://schemas.openxmlformats.org/officeDocument/2006/relationships" r:dm="rIdDm1" r:lo="rIdLo1" r:qs="rIdQs1" r:cs="rIdCs1"/>
+          </a:graphicData>
+        </a:graphic>
+      </p:graphicFrame>
+    </p:spTree>
+  </p:cSld>
+</p:sld>
+</file>
+
+<file path=ppt/slides/slide7.xml><?xml version="1.0" encoding="utf-8"?>
+<p:sld xmlns:p="http://schemas.openxmlformats.org/presentationml/2006/main" xmlns:a="http://schemas.openxmlformats.org/drawingml/2006/main" xmlns:r="http://schemas.openxmlformats.org/officeDocument/2006/relationships">
+  <p:cSld>
+    <p:spTree>
+      <p:nvGrpSpPr>
+        <p:cNvPr id="1" name=""/>
+        <p:cNvGrpSpPr/>
+        <p:nvPr/>
+      </p:nvGrpSpPr>
+      <p:grpSpPr>
+        <a:xfrm>
+          <a:off x="0" y="0"/>
+          <a:ext cx="0" cy="0"/>
+          <a:chOff x="0" y="0"/>
+          <a:chExt cx="0" cy="0"/>
+        </a:xfrm>
+      </p:grpSpPr>
+      <p:sp>
+        <p:nvSpPr>
+          <p:cNvPr id="2" name="Title"/>
+          <p:cNvSpPr/>
+          <p:nvPr/>
+        </p:nvSpPr>
+        <p:spPr>
+          <a:xfrm>
+            <a:off x="457200" y="130000"/>
+            <a:ext cx="8229600" cy="430000"/>
+          </a:xfrm>
+          <a:prstGeom prst="rect">
+            <a:avLst/>
+          </a:prstGeom>
+          <a:noFill/>
+        </p:spPr>
+        <p:txBody>
+          <a:bodyPr/>
+          <a:lstStyle/>
+          <a:p>
+            <a:r>
+              <a:rPr lang="en-US" sz="1800" b="1"/>
+              <a:t>SmartArt Live - Relationship1</a:t>
+            </a:r>
+          </a:p>
+        </p:txBody>
+      </p:sp>
+      <p:graphicFrame>
+        <p:nvGraphicFramePr>
+          <p:cNvPr id="3" name="SmartArt 7"/>
           <p:cNvGraphicFramePr/>
           <p:nvPr/>
         </p:nvGraphicFramePr>

</xml_diff>

<commit_message>
FreeP: admit gridMatrix SmartArt import grammar
</commit_message>
<xml_diff>
--- a/tools/FreeP.RenderCompare/corpus/15-smartart-grouped-list.pptx
+++ b/tools/FreeP.RenderCompare/corpus/15-smartart-grouped-list.pptx
@@ -12,6 +12,7 @@
     <p:sldId id="260" r:id="rIdSlide5"/>
     <p:sldId id="261" r:id="rIdSlide6"/>
     <p:sldId id="262" r:id="rIdSlide7"/>
+    <p:sldId id="263" r:id="rIdSlide8"/>
   </p:sldIdLst>
   <p:sldSz cx="9144000" cy="6858000"/>
   <p:notesSz cx="6858000" cy="9144000"/>
@@ -51,6 +52,10 @@
 <dgm:colorsDef xmlns:dgm="http://schemas.openxmlformats.org/drawingml/2006/diagram"/>
 </file>
 
+<file path=ppt/diagrams/colors8.xml><?xml version="1.0" encoding="utf-8"?>
+<dgm:colorsDef xmlns:dgm="http://schemas.openxmlformats.org/drawingml/2006/diagram"/>
+</file>
+
 <file path=ppt/diagrams/data1.xml><?xml version="1.0" encoding="utf-8"?>
 <dgm:dataModel xmlns:dgm="http://schemas.openxmlformats.org/drawingml/2006/diagram" xmlns:a="http://schemas.openxmlformats.org/drawingml/2006/main">
   <dgm:ptLst>
@@ -435,6 +440,54 @@
 </dgm:dataModel>
 </file>
 
+<file path=ppt/diagrams/data8.xml><?xml version="1.0" encoding="utf-8"?>
+<dgm:dataModel xmlns:dgm="http://schemas.openxmlformats.org/drawingml/2006/diagram" xmlns:a="http://schemas.openxmlformats.org/drawingml/2006/main">
+  <dgm:ptLst>
+    <dgm:pt modelId="grid1" type="node">
+      <dgm:t>
+        <a:p>
+          <a:r>
+            <a:rPr lang="en-US"/>
+            <a:t>Axis</a:t>
+          </a:r>
+        </a:p>
+      </dgm:t>
+    </dgm:pt>
+    <dgm:pt modelId="grid2" type="node">
+      <dgm:t>
+        <a:p>
+          <a:r>
+            <a:rPr lang="en-US"/>
+            <a:t>Speed</a:t>
+          </a:r>
+        </a:p>
+      </dgm:t>
+    </dgm:pt>
+    <dgm:pt modelId="grid3" type="node">
+      <dgm:t>
+        <a:p>
+          <a:r>
+            <a:rPr lang="en-US"/>
+            <a:t>Quality</a:t>
+          </a:r>
+        </a:p>
+      </dgm:t>
+    </dgm:pt>
+    <dgm:pt modelId="grid4" type="node">
+      <dgm:t>
+        <a:p>
+          <a:r>
+            <a:rPr lang="en-US"/>
+            <a:t>Cost</a:t>
+          </a:r>
+        </a:p>
+      </dgm:t>
+    </dgm:pt>
+  </dgm:ptLst>
+  <dgm:cxnLst/>
+</dgm:dataModel>
+</file>
+
 <file path=ppt/diagrams/drawing1.xml><?xml version="1.0" encoding="utf-8"?>
 <dsp:drawing xmlns:dsp="http://schemas.microsoft.com/office/drawing/2008/diagram">
   <dsp:spTree/>
@@ -1026,6 +1079,133 @@
 </dsp:drawing>
 </file>
 
+<file path=ppt/diagrams/drawing8.xml><?xml version="1.0" encoding="utf-8"?>
+<dsp:drawing xmlns:dsp="http://schemas.microsoft.com/office/drawing/2008/diagram" xmlns:a="http://schemas.openxmlformats.org/drawingml/2006/main">
+  <dsp:spTree>
+    <dsp:sp>
+      <dsp:nvSpPr>
+        <dsp:cNvPr id="80" name="GridMatrix cell 1"/>
+        <dsp:cNvSpPr/>
+        <dsp:nvPr/>
+      </dsp:nvSpPr>
+      <dsp:spPr>
+        <a:xfrm>
+          <a:off x="1472192" y="229792"/>
+          <a:ext cx="2576543" cy="2576543"/>
+        </a:xfrm>
+        <a:prstGeom prst="rect">
+          <a:avLst/>
+        </a:prstGeom>
+        <a:solidFill>
+          <a:srgbClr val="4472C4"/>
+        </a:solidFill>
+        <a:ln/>
+      </dsp:spPr>
+      <dsp:txBody>
+        <a:bodyPr/>
+        <a:lstStyle/>
+        <a:p>
+          <a:r>
+            <a:rPr lang="en-US"/>
+            <a:t>Axis</a:t>
+          </a:r>
+        </a:p>
+      </dsp:txBody>
+    </dsp:sp>
+    <dsp:sp>
+      <dsp:nvSpPr>
+        <dsp:cNvPr id="81" name="GridMatrix cell 2"/>
+        <dsp:cNvSpPr/>
+        <dsp:nvPr/>
+      </dsp:nvSpPr>
+      <dsp:spPr>
+        <a:xfrm>
+          <a:off x="4180865" y="229792"/>
+          <a:ext cx="2576543" cy="2576543"/>
+        </a:xfrm>
+        <a:prstGeom prst="rect">
+          <a:avLst/>
+        </a:prstGeom>
+        <a:solidFill>
+          <a:srgbClr val="4472C4"/>
+        </a:solidFill>
+        <a:ln/>
+      </dsp:spPr>
+      <dsp:txBody>
+        <a:bodyPr/>
+        <a:lstStyle/>
+        <a:p>
+          <a:r>
+            <a:rPr lang="en-US"/>
+            <a:t>Speed</a:t>
+          </a:r>
+        </a:p>
+      </dsp:txBody>
+    </dsp:sp>
+    <dsp:sp>
+      <dsp:nvSpPr>
+        <dsp:cNvPr id="82" name="GridMatrix cell 3"/>
+        <dsp:cNvSpPr/>
+        <dsp:nvPr/>
+      </dsp:nvSpPr>
+      <dsp:spPr>
+        <a:xfrm>
+          <a:off x="1472192" y="2938465"/>
+          <a:ext cx="2576543" cy="2576543"/>
+        </a:xfrm>
+        <a:prstGeom prst="rect">
+          <a:avLst/>
+        </a:prstGeom>
+        <a:solidFill>
+          <a:srgbClr val="4472C4"/>
+        </a:solidFill>
+        <a:ln/>
+      </dsp:spPr>
+      <dsp:txBody>
+        <a:bodyPr/>
+        <a:lstStyle/>
+        <a:p>
+          <a:r>
+            <a:rPr lang="en-US"/>
+            <a:t>Quality</a:t>
+          </a:r>
+        </a:p>
+      </dsp:txBody>
+    </dsp:sp>
+    <dsp:sp>
+      <dsp:nvSpPr>
+        <dsp:cNvPr id="83" name="GridMatrix cell 4"/>
+        <dsp:cNvSpPr/>
+        <dsp:nvPr/>
+      </dsp:nvSpPr>
+      <dsp:spPr>
+        <a:xfrm>
+          <a:off x="4180865" y="2938465"/>
+          <a:ext cx="2576543" cy="2576543"/>
+        </a:xfrm>
+        <a:prstGeom prst="rect">
+          <a:avLst/>
+        </a:prstGeom>
+        <a:solidFill>
+          <a:srgbClr val="4472C4"/>
+        </a:solidFill>
+        <a:ln/>
+      </dsp:spPr>
+      <dsp:txBody>
+        <a:bodyPr/>
+        <a:lstStyle/>
+        <a:p>
+          <a:r>
+            <a:rPr lang="en-US"/>
+            <a:t>Cost</a:t>
+          </a:r>
+        </a:p>
+      </dsp:txBody>
+    </dsp:sp>
+  </dsp:spTree>
+</dsp:drawing>
+</file>
+
 <file path=ppt/diagrams/layout1.xml><?xml version="1.0" encoding="utf-8"?>
 <dgm:layoutDef xmlns:dgm="http://schemas.openxmlformats.org/drawingml/2006/diagram" uniqueId="urn:microsoft.com/office/officeart/2005/8/layout/process1"/>
 </file>
@@ -1054,6 +1234,10 @@
 <dgm:layoutDef xmlns:dgm="http://schemas.openxmlformats.org/drawingml/2006/diagram" uniqueId="urn:microsoft.com/office/officeart/2005/8/layout/relationship1"/>
 </file>
 
+<file path=ppt/diagrams/layout8.xml><?xml version="1.0" encoding="utf-8"?>
+<dgm:layoutDef xmlns:dgm="http://schemas.openxmlformats.org/drawingml/2006/diagram" uniqueId="urn:microsoft.com/office/officeart/2005/8/layout/gridMatrix"/>
+</file>
+
 <file path=ppt/diagrams/quickStyle1.xml><?xml version="1.0" encoding="utf-8"?>
 <dgm:styleDef xmlns:dgm="http://schemas.openxmlformats.org/drawingml/2006/diagram"/>
 </file>
@@ -1079,6 +1263,10 @@
 </file>
 
 <file path=ppt/diagrams/quickStyle7.xml><?xml version="1.0" encoding="utf-8"?>
+<dgm:styleDef xmlns:dgm="http://schemas.openxmlformats.org/drawingml/2006/diagram"/>
+</file>
+
+<file path=ppt/diagrams/quickStyle8.xml><?xml version="1.0" encoding="utf-8"?>
 <dgm:styleDef xmlns:dgm="http://schemas.openxmlformats.org/drawingml/2006/diagram"/>
 </file>
 
@@ -1564,6 +1752,71 @@
       <p:graphicFrame>
         <p:nvGraphicFramePr>
           <p:cNvPr id="3" name="SmartArt 7"/>
+          <p:cNvGraphicFramePr/>
+          <p:nvPr/>
+        </p:nvGraphicFramePr>
+        <p:xfrm>
+          <a:off x="457200" y="680000"/>
+          <a:ext cx="8229600" cy="5744800"/>
+        </p:xfrm>
+        <a:graphic>
+          <a:graphicData uri="http://schemas.openxmlformats.org/drawingml/2006/diagram">
+            <dgm:relIds xmlns:dgm="http://schemas.openxmlformats.org/drawingml/2006/diagram" xmlns:r="http://schemas.openxmlformats.org/officeDocument/2006/relationships" r:dm="rIdDm1" r:lo="rIdLo1" r:qs="rIdQs1" r:cs="rIdCs1"/>
+          </a:graphicData>
+        </a:graphic>
+      </p:graphicFrame>
+    </p:spTree>
+  </p:cSld>
+</p:sld>
+</file>
+
+<file path=ppt/slides/slide8.xml><?xml version="1.0" encoding="utf-8"?>
+<p:sld xmlns:p="http://schemas.openxmlformats.org/presentationml/2006/main" xmlns:a="http://schemas.openxmlformats.org/drawingml/2006/main" xmlns:r="http://schemas.openxmlformats.org/officeDocument/2006/relationships">
+  <p:cSld>
+    <p:spTree>
+      <p:nvGrpSpPr>
+        <p:cNvPr id="1" name=""/>
+        <p:cNvGrpSpPr/>
+        <p:nvPr/>
+      </p:nvGrpSpPr>
+      <p:grpSpPr>
+        <a:xfrm>
+          <a:off x="0" y="0"/>
+          <a:ext cx="0" cy="0"/>
+          <a:chOff x="0" y="0"/>
+          <a:chExt cx="0" cy="0"/>
+        </a:xfrm>
+      </p:grpSpPr>
+      <p:sp>
+        <p:nvSpPr>
+          <p:cNvPr id="2" name="Title"/>
+          <p:cNvSpPr/>
+          <p:nvPr/>
+        </p:nvSpPr>
+        <p:spPr>
+          <a:xfrm>
+            <a:off x="457200" y="130000"/>
+            <a:ext cx="8229600" cy="430000"/>
+          </a:xfrm>
+          <a:prstGeom prst="rect">
+            <a:avLst/>
+          </a:prstGeom>
+          <a:noFill/>
+        </p:spPr>
+        <p:txBody>
+          <a:bodyPr/>
+          <a:lstStyle/>
+          <a:p>
+            <a:r>
+              <a:rPr lang="en-US" sz="1800" b="1"/>
+              <a:t>SmartArt Live - Grid Matrix</a:t>
+            </a:r>
+          </a:p>
+        </p:txBody>
+      </p:sp>
+      <p:graphicFrame>
+        <p:nvGraphicFramePr>
+          <p:cNvPr id="3" name="SmartArt 8"/>
           <p:cNvGraphicFramePr/>
           <p:nvPr/>
         </p:nvGraphicFramePr>

</xml_diff>

<commit_message>
FreeP: admit bounded increasing circle SmartArt import
</commit_message>
<xml_diff>
--- a/tools/FreeP.RenderCompare/corpus/15-smartart-grouped-list.pptx
+++ b/tools/FreeP.RenderCompare/corpus/15-smartart-grouped-list.pptx
@@ -13,6 +13,7 @@
     <p:sldId id="261" r:id="rIdSlide6"/>
     <p:sldId id="262" r:id="rIdSlide7"/>
     <p:sldId id="263" r:id="rIdSlide8"/>
+    <p:sldId id="264" r:id="rIdSlide9"/>
   </p:sldIdLst>
   <p:sldSz cx="9144000" cy="6858000"/>
   <p:notesSz cx="6858000" cy="9144000"/>
@@ -56,6 +57,10 @@
 <dgm:colorsDef xmlns:dgm="http://schemas.openxmlformats.org/drawingml/2006/diagram"/>
 </file>
 
+<file path=ppt/diagrams/colors9.xml><?xml version="1.0" encoding="utf-8"?>
+<dgm:colorsDef xmlns:dgm="http://schemas.openxmlformats.org/drawingml/2006/diagram"/>
+</file>
+
 <file path=ppt/diagrams/data1.xml><?xml version="1.0" encoding="utf-8"?>
 <dgm:dataModel xmlns:dgm="http://schemas.openxmlformats.org/drawingml/2006/diagram" xmlns:a="http://schemas.openxmlformats.org/drawingml/2006/main">
   <dgm:ptLst>
@@ -488,6 +493,58 @@
 </dgm:dataModel>
 </file>
 
+<file path=ppt/diagrams/data9.xml><?xml version="1.0" encoding="utf-8"?>
+<dgm:dataModel xmlns:dgm="http://schemas.openxmlformats.org/drawingml/2006/diagram" xmlns:a="http://schemas.openxmlformats.org/drawingml/2006/main">
+  <dgm:ptLst>
+    <dgm:pt modelId="inc1" type="node">
+      <dgm:t>
+        <a:p>
+          <a:r>
+            <a:rPr lang="en-US"/>
+            <a:t>Phase A</a:t>
+          </a:r>
+        </a:p>
+      </dgm:t>
+    </dgm:pt>
+    <dgm:pt modelId="inc2" type="node">
+      <dgm:t>
+        <a:p>
+          <a:r>
+            <a:rPr lang="en-US"/>
+            <a:t>Phase B</a:t>
+          </a:r>
+        </a:p>
+      </dgm:t>
+    </dgm:pt>
+    <dgm:pt modelId="inc3" type="node">
+      <dgm:t>
+        <a:p>
+          <a:r>
+            <a:rPr lang="en-US"/>
+            <a:t>Phase C</a:t>
+          </a:r>
+        </a:p>
+      </dgm:t>
+    </dgm:pt>
+    <dgm:pt modelId="inc4" type="node">
+      <dgm:t>
+        <a:p>
+          <a:r>
+            <a:rPr lang="en-US"/>
+            <a:t>Phase D</a:t>
+          </a:r>
+        </a:p>
+      </dgm:t>
+    </dgm:pt>
+  </dgm:ptLst>
+  <dgm:cxnLst>
+    <dgm:cxn type="parOf" srcId="inc1" destId="inc2"/>
+    <dgm:cxn type="parOf" srcId="inc2" destId="inc3"/>
+    <dgm:cxn type="parOf" srcId="inc3" destId="inc4"/>
+  </dgm:cxnLst>
+</dgm:dataModel>
+</file>
+
 <file path=ppt/diagrams/drawing1.xml><?xml version="1.0" encoding="utf-8"?>
 <dsp:drawing xmlns:dsp="http://schemas.microsoft.com/office/drawing/2008/diagram">
   <dsp:spTree/>
@@ -1206,6 +1263,190 @@
 </dsp:drawing>
 </file>
 
+<file path=ppt/diagrams/drawing9.xml><?xml version="1.0" encoding="utf-8"?>
+<dsp:drawing xmlns:dsp="http://schemas.microsoft.com/office/drawing/2008/diagram" xmlns:a="http://schemas.openxmlformats.org/drawingml/2006/main">
+  <dsp:spTree>
+    <dsp:sp>
+      <dsp:nvSpPr>
+        <dsp:cNvPr id="90" name="IncreasingCircleProcess node 1"/>
+        <dsp:cNvSpPr/>
+        <dsp:nvPr/>
+      </dsp:nvSpPr>
+      <dsp:spPr>
+        <a:xfrm>
+          <a:off x="329184" y="4317060"/>
+          <a:ext cx="1197948" cy="1197948"/>
+        </a:xfrm>
+        <a:prstGeom prst="ellipse">
+          <a:avLst/>
+        </a:prstGeom>
+        <a:solidFill>
+          <a:srgbClr val="4472C4"/>
+        </a:solidFill>
+        <a:ln/>
+      </dsp:spPr>
+      <dsp:txBody>
+        <a:bodyPr/>
+        <a:lstStyle/>
+        <a:p>
+          <a:r>
+            <a:rPr lang="en-US"/>
+            <a:t>Phase A</a:t>
+          </a:r>
+        </a:p>
+      </dsp:txBody>
+    </dsp:sp>
+    <dsp:sp>
+      <dsp:nvSpPr>
+        <dsp:cNvPr id="91" name="IncreasingCircleProcess node 2"/>
+        <dsp:cNvSpPr/>
+        <dsp:nvPr/>
+      </dsp:nvSpPr>
+      <dsp:spPr>
+        <a:xfrm>
+          <a:off x="1716412" y="3948461"/>
+          <a:ext cx="1566547" cy="1566547"/>
+        </a:xfrm>
+        <a:prstGeom prst="ellipse">
+          <a:avLst/>
+        </a:prstGeom>
+        <a:solidFill>
+          <a:srgbClr val="4472C4"/>
+        </a:solidFill>
+        <a:ln/>
+      </dsp:spPr>
+      <dsp:txBody>
+        <a:bodyPr/>
+        <a:lstStyle/>
+        <a:p>
+          <a:r>
+            <a:rPr lang="en-US"/>
+            <a:t>Phase B</a:t>
+          </a:r>
+        </a:p>
+      </dsp:txBody>
+    </dsp:sp>
+    <dsp:sp>
+      <dsp:nvSpPr>
+        <dsp:cNvPr id="92" name="IncreasingCircleProcess node 3"/>
+        <dsp:cNvSpPr/>
+        <dsp:nvPr/>
+      </dsp:nvSpPr>
+      <dsp:spPr>
+        <a:xfrm>
+          <a:off x="3472239" y="3579861"/>
+          <a:ext cx="1935147" cy="1935147"/>
+        </a:xfrm>
+        <a:prstGeom prst="ellipse">
+          <a:avLst/>
+        </a:prstGeom>
+        <a:solidFill>
+          <a:srgbClr val="4472C4"/>
+        </a:solidFill>
+        <a:ln/>
+      </dsp:spPr>
+      <dsp:txBody>
+        <a:bodyPr/>
+        <a:lstStyle/>
+        <a:p>
+          <a:r>
+            <a:rPr lang="en-US"/>
+            <a:t>Phase C</a:t>
+          </a:r>
+        </a:p>
+      </dsp:txBody>
+    </dsp:sp>
+    <dsp:sp>
+      <dsp:nvSpPr>
+        <dsp:cNvPr id="93" name="IncreasingCircleProcess node 4"/>
+        <dsp:cNvSpPr/>
+        <dsp:nvPr/>
+      </dsp:nvSpPr>
+      <dsp:spPr>
+        <a:xfrm>
+          <a:off x="5596666" y="3211261"/>
+          <a:ext cx="2303747" cy="2303747"/>
+        </a:xfrm>
+        <a:prstGeom prst="ellipse">
+          <a:avLst/>
+        </a:prstGeom>
+        <a:solidFill>
+          <a:srgbClr val="4472C4"/>
+        </a:solidFill>
+        <a:ln/>
+      </dsp:spPr>
+      <dsp:txBody>
+        <a:bodyPr/>
+        <a:lstStyle/>
+        <a:p>
+          <a:r>
+            <a:rPr lang="en-US"/>
+            <a:t>Phase D</a:t>
+          </a:r>
+        </a:p>
+      </dsp:txBody>
+    </dsp:sp>
+    <dsp:sp>
+      <dsp:nvSpPr>
+        <dsp:cNvPr id="100" name="IncreasingCircleProcess connector 1"/>
+        <dsp:cNvSpPr/>
+        <dsp:nvPr/>
+      </dsp:nvSpPr>
+      <dsp:spPr>
+        <a:xfrm>
+          <a:off x="1527132" y="4731734"/>
+          <a:ext cx="189280" cy="184300"/>
+        </a:xfrm>
+        <a:ln>
+          <a:solidFill>
+            <a:srgbClr val="0E4B66"/>
+          </a:solidFill>
+          <a:prstDash val="solid"/>
+        </a:ln>
+      </dsp:spPr>
+    </dsp:sp>
+    <dsp:sp>
+      <dsp:nvSpPr>
+        <dsp:cNvPr id="101" name="IncreasingCircleProcess connector 2"/>
+        <dsp:cNvSpPr/>
+        <dsp:nvPr/>
+      </dsp:nvSpPr>
+      <dsp:spPr>
+        <a:xfrm>
+          <a:off x="3282959" y="4547434"/>
+          <a:ext cx="189280" cy="184300"/>
+        </a:xfrm>
+        <a:ln>
+          <a:solidFill>
+            <a:srgbClr val="0E4B66"/>
+          </a:solidFill>
+          <a:prstDash val="solid"/>
+        </a:ln>
+      </dsp:spPr>
+    </dsp:sp>
+    <dsp:sp>
+      <dsp:nvSpPr>
+        <dsp:cNvPr id="102" name="IncreasingCircleProcess connector 3"/>
+        <dsp:cNvSpPr/>
+        <dsp:nvPr/>
+      </dsp:nvSpPr>
+      <dsp:spPr>
+        <a:xfrm>
+          <a:off x="5407386" y="4363134"/>
+          <a:ext cx="189280" cy="184300"/>
+        </a:xfrm>
+        <a:ln>
+          <a:solidFill>
+            <a:srgbClr val="0E4B66"/>
+          </a:solidFill>
+          <a:prstDash val="solid"/>
+        </a:ln>
+      </dsp:spPr>
+    </dsp:sp>
+  </dsp:spTree>
+</dsp:drawing>
+</file>
+
 <file path=ppt/diagrams/layout1.xml><?xml version="1.0" encoding="utf-8"?>
 <dgm:layoutDef xmlns:dgm="http://schemas.openxmlformats.org/drawingml/2006/diagram" uniqueId="urn:microsoft.com/office/officeart/2005/8/layout/process1"/>
 </file>
@@ -1238,6 +1479,10 @@
 <dgm:layoutDef xmlns:dgm="http://schemas.openxmlformats.org/drawingml/2006/diagram" uniqueId="urn:microsoft.com/office/officeart/2005/8/layout/gridMatrix"/>
 </file>
 
+<file path=ppt/diagrams/layout9.xml><?xml version="1.0" encoding="utf-8"?>
+<dgm:layoutDef xmlns:dgm="http://schemas.openxmlformats.org/drawingml/2006/diagram" uniqueId="urn:microsoft.com/office/officeart/2005/8/layout/increasingCircleProcess"/>
+</file>
+
 <file path=ppt/diagrams/quickStyle1.xml><?xml version="1.0" encoding="utf-8"?>
 <dgm:styleDef xmlns:dgm="http://schemas.openxmlformats.org/drawingml/2006/diagram"/>
 </file>
@@ -1267,6 +1512,10 @@
 </file>
 
 <file path=ppt/diagrams/quickStyle8.xml><?xml version="1.0" encoding="utf-8"?>
+<dgm:styleDef xmlns:dgm="http://schemas.openxmlformats.org/drawingml/2006/diagram"/>
+</file>
+
+<file path=ppt/diagrams/quickStyle9.xml><?xml version="1.0" encoding="utf-8"?>
 <dgm:styleDef xmlns:dgm="http://schemas.openxmlformats.org/drawingml/2006/diagram"/>
 </file>
 
@@ -1817,6 +2066,71 @@
       <p:graphicFrame>
         <p:nvGraphicFramePr>
           <p:cNvPr id="3" name="SmartArt 8"/>
+          <p:cNvGraphicFramePr/>
+          <p:nvPr/>
+        </p:nvGraphicFramePr>
+        <p:xfrm>
+          <a:off x="457200" y="680000"/>
+          <a:ext cx="8229600" cy="5744800"/>
+        </p:xfrm>
+        <a:graphic>
+          <a:graphicData uri="http://schemas.openxmlformats.org/drawingml/2006/diagram">
+            <dgm:relIds xmlns:dgm="http://schemas.openxmlformats.org/drawingml/2006/diagram" xmlns:r="http://schemas.openxmlformats.org/officeDocument/2006/relationships" r:dm="rIdDm1" r:lo="rIdLo1" r:qs="rIdQs1" r:cs="rIdCs1"/>
+          </a:graphicData>
+        </a:graphic>
+      </p:graphicFrame>
+    </p:spTree>
+  </p:cSld>
+</p:sld>
+</file>
+
+<file path=ppt/slides/slide9.xml><?xml version="1.0" encoding="utf-8"?>
+<p:sld xmlns:p="http://schemas.openxmlformats.org/presentationml/2006/main" xmlns:a="http://schemas.openxmlformats.org/drawingml/2006/main" xmlns:r="http://schemas.openxmlformats.org/officeDocument/2006/relationships">
+  <p:cSld>
+    <p:spTree>
+      <p:nvGrpSpPr>
+        <p:cNvPr id="1" name=""/>
+        <p:cNvGrpSpPr/>
+        <p:nvPr/>
+      </p:nvGrpSpPr>
+      <p:grpSpPr>
+        <a:xfrm>
+          <a:off x="0" y="0"/>
+          <a:ext cx="0" cy="0"/>
+          <a:chOff x="0" y="0"/>
+          <a:chExt cx="0" cy="0"/>
+        </a:xfrm>
+      </p:grpSpPr>
+      <p:sp>
+        <p:nvSpPr>
+          <p:cNvPr id="2" name="Title"/>
+          <p:cNvSpPr/>
+          <p:nvPr/>
+        </p:nvSpPr>
+        <p:spPr>
+          <a:xfrm>
+            <a:off x="457200" y="130000"/>
+            <a:ext cx="8229600" cy="430000"/>
+          </a:xfrm>
+          <a:prstGeom prst="rect">
+            <a:avLst/>
+          </a:prstGeom>
+          <a:noFill/>
+        </p:spPr>
+        <p:txBody>
+          <a:bodyPr/>
+          <a:lstStyle/>
+          <a:p>
+            <a:r>
+              <a:rPr lang="en-US" sz="1800" b="1"/>
+              <a:t>SmartArt Live - Increasing Circle Process</a:t>
+            </a:r>
+          </a:p>
+        </p:txBody>
+      </p:sp>
+      <p:graphicFrame>
+        <p:nvGraphicFramePr>
+          <p:cNvPr id="3" name="SmartArt 9"/>
           <p:cNvGraphicFramePr/>
           <p:nvPr/>
         </p:nvGraphicFramePr>

</xml_diff>

<commit_message>
FreeP: admit strict vertical arrow SmartArt cache
</commit_message>
<xml_diff>
--- a/tools/FreeP.RenderCompare/corpus/15-smartart-grouped-list.pptx
+++ b/tools/FreeP.RenderCompare/corpus/15-smartart-grouped-list.pptx
@@ -14,6 +14,7 @@
     <p:sldId id="262" r:id="rIdSlide7"/>
     <p:sldId id="263" r:id="rIdSlide8"/>
     <p:sldId id="264" r:id="rIdSlide9"/>
+    <p:sldId id="265" r:id="rIdSlide10"/>
   </p:sldIdLst>
   <p:sldSz cx="9144000" cy="6858000"/>
   <p:notesSz cx="6858000" cy="9144000"/>
@@ -29,6 +30,10 @@
 <dgm:colorsDef xmlns:dgm="http://schemas.openxmlformats.org/drawingml/2006/diagram"/>
 </file>
 
+<file path=ppt/diagrams/colors10.xml><?xml version="1.0" encoding="utf-8"?>
+<dgm:colorsDef xmlns:dgm="http://schemas.openxmlformats.org/drawingml/2006/diagram"/>
+</file>
+
 <file path=ppt/diagrams/colors2.xml><?xml version="1.0" encoding="utf-8"?>
 <dgm:colorsDef xmlns:dgm="http://schemas.openxmlformats.org/drawingml/2006/diagram"/>
 </file>
@@ -124,6 +129,54 @@
 </dgm:dataModel>
 </file>
 
+<file path=ppt/diagrams/data10.xml><?xml version="1.0" encoding="utf-8"?>
+<dgm:dataModel xmlns:dgm="http://schemas.openxmlformats.org/drawingml/2006/diagram" xmlns:a="http://schemas.openxmlformats.org/drawingml/2006/main">
+  <dgm:ptLst>
+    <dgm:pt modelId="va1" type="node">
+      <dgm:t>
+        <a:p>
+          <a:r>
+            <a:rPr lang="en-US"/>
+            <a:t>Collect</a:t>
+          </a:r>
+        </a:p>
+      </dgm:t>
+    </dgm:pt>
+    <dgm:pt modelId="va2" type="node">
+      <dgm:t>
+        <a:p>
+          <a:r>
+            <a:rPr lang="en-US"/>
+            <a:t>Shape</a:t>
+          </a:r>
+        </a:p>
+      </dgm:t>
+    </dgm:pt>
+    <dgm:pt modelId="va3" type="node">
+      <dgm:t>
+        <a:p>
+          <a:r>
+            <a:rPr lang="en-US"/>
+            <a:t>Review</a:t>
+          </a:r>
+        </a:p>
+      </dgm:t>
+    </dgm:pt>
+    <dgm:pt modelId="va4" type="node">
+      <dgm:t>
+        <a:p>
+          <a:r>
+            <a:rPr lang="en-US"/>
+            <a:t>Share</a:t>
+          </a:r>
+        </a:p>
+      </dgm:t>
+    </dgm:pt>
+  </dgm:ptLst>
+  <dgm:cxnLst/>
+</dgm:dataModel>
+</file>
+
 <file path=ppt/diagrams/data2.xml><?xml version="1.0" encoding="utf-8"?>
 <dgm:dataModel xmlns:dgm="http://schemas.openxmlformats.org/drawingml/2006/diagram" xmlns:a="http://schemas.openxmlformats.org/drawingml/2006/main">
   <dgm:ptLst>
@@ -551,6 +604,133 @@
 </dsp:drawing>
 </file>
 
+<file path=ppt/diagrams/drawing10.xml><?xml version="1.0" encoding="utf-8"?>
+<dsp:drawing xmlns:dsp="http://schemas.microsoft.com/office/drawing/2008/diagram" xmlns:a="http://schemas.openxmlformats.org/drawingml/2006/main">
+  <dsp:spTree>
+    <dsp:sp>
+      <dsp:nvSpPr>
+        <dsp:cNvPr id="110" name="VerticalArrowList node 1"/>
+        <dsp:cNvSpPr/>
+        <dsp:nvPr/>
+      </dsp:nvSpPr>
+      <dsp:spPr>
+        <a:xfrm>
+          <a:off x="329184" y="229792"/>
+          <a:ext cx="7571232" cy="1251289"/>
+        </a:xfrm>
+        <a:prstGeom prst="downArrow">
+          <a:avLst/>
+        </a:prstGeom>
+        <a:solidFill>
+          <a:srgbClr val="4472C4"/>
+        </a:solidFill>
+        <a:ln/>
+      </dsp:spPr>
+      <dsp:txBody>
+        <a:bodyPr/>
+        <a:lstStyle/>
+        <a:p>
+          <a:r>
+            <a:rPr lang="en-US"/>
+            <a:t>Collect</a:t>
+          </a:r>
+        </a:p>
+      </dsp:txBody>
+    </dsp:sp>
+    <dsp:sp>
+      <dsp:nvSpPr>
+        <dsp:cNvPr id="111" name="VerticalArrowList node 2"/>
+        <dsp:cNvSpPr/>
+        <dsp:nvPr/>
+      </dsp:nvSpPr>
+      <dsp:spPr>
+        <a:xfrm>
+          <a:off x="329184" y="1574434"/>
+          <a:ext cx="7571232" cy="1251289"/>
+        </a:xfrm>
+        <a:prstGeom prst="downArrow">
+          <a:avLst/>
+        </a:prstGeom>
+        <a:solidFill>
+          <a:srgbClr val="4472C4"/>
+        </a:solidFill>
+        <a:ln/>
+      </dsp:spPr>
+      <dsp:txBody>
+        <a:bodyPr/>
+        <a:lstStyle/>
+        <a:p>
+          <a:r>
+            <a:rPr lang="en-US"/>
+            <a:t>Shape</a:t>
+          </a:r>
+        </a:p>
+      </dsp:txBody>
+    </dsp:sp>
+    <dsp:sp>
+      <dsp:nvSpPr>
+        <dsp:cNvPr id="112" name="VerticalArrowList node 3"/>
+        <dsp:cNvSpPr/>
+        <dsp:nvPr/>
+      </dsp:nvSpPr>
+      <dsp:spPr>
+        <a:xfrm>
+          <a:off x="329184" y="2919076"/>
+          <a:ext cx="7571232" cy="1251289"/>
+        </a:xfrm>
+        <a:prstGeom prst="downArrow">
+          <a:avLst/>
+        </a:prstGeom>
+        <a:solidFill>
+          <a:srgbClr val="4472C4"/>
+        </a:solidFill>
+        <a:ln/>
+      </dsp:spPr>
+      <dsp:txBody>
+        <a:bodyPr/>
+        <a:lstStyle/>
+        <a:p>
+          <a:r>
+            <a:rPr lang="en-US"/>
+            <a:t>Review</a:t>
+          </a:r>
+        </a:p>
+      </dsp:txBody>
+    </dsp:sp>
+    <dsp:sp>
+      <dsp:nvSpPr>
+        <dsp:cNvPr id="113" name="VerticalArrowList node 4"/>
+        <dsp:cNvSpPr/>
+        <dsp:nvPr/>
+      </dsp:nvSpPr>
+      <dsp:spPr>
+        <a:xfrm>
+          <a:off x="329184" y="4263718"/>
+          <a:ext cx="7571232" cy="1251289"/>
+        </a:xfrm>
+        <a:prstGeom prst="downArrow">
+          <a:avLst/>
+        </a:prstGeom>
+        <a:solidFill>
+          <a:srgbClr val="4472C4"/>
+        </a:solidFill>
+        <a:ln/>
+      </dsp:spPr>
+      <dsp:txBody>
+        <a:bodyPr/>
+        <a:lstStyle/>
+        <a:p>
+          <a:r>
+            <a:rPr lang="en-US"/>
+            <a:t>Share</a:t>
+          </a:r>
+        </a:p>
+      </dsp:txBody>
+    </dsp:sp>
+  </dsp:spTree>
+</dsp:drawing>
+</file>
+
 <file path=ppt/diagrams/drawing2.xml><?xml version="1.0" encoding="utf-8"?>
 <dsp:drawing xmlns:dsp="http://schemas.microsoft.com/office/drawing/2008/diagram">
   <dsp:spTree/>
@@ -1451,6 +1631,10 @@
 <dgm:layoutDef xmlns:dgm="http://schemas.openxmlformats.org/drawingml/2006/diagram" uniqueId="urn:microsoft.com/office/officeart/2005/8/layout/process1"/>
 </file>
 
+<file path=ppt/diagrams/layout10.xml><?xml version="1.0" encoding="utf-8"?>
+<dgm:layoutDef xmlns:dgm="http://schemas.openxmlformats.org/drawingml/2006/diagram" uniqueId="urn:microsoft.com/office/officeart/2005/8/layout/verticalArrowList"/>
+</file>
+
 <file path=ppt/diagrams/layout2.xml><?xml version="1.0" encoding="utf-8"?>
 <dgm:layoutDef xmlns:dgm="http://schemas.openxmlformats.org/drawingml/2006/diagram" uniqueId="urn:microsoft.com/office/officeart/2005/8/layout/hierarchy1"/>
 </file>
@@ -1484,6 +1668,10 @@
 </file>
 
 <file path=ppt/diagrams/quickStyle1.xml><?xml version="1.0" encoding="utf-8"?>
+<dgm:styleDef xmlns:dgm="http://schemas.openxmlformats.org/drawingml/2006/diagram"/>
+</file>
+
+<file path=ppt/diagrams/quickStyle10.xml><?xml version="1.0" encoding="utf-8"?>
 <dgm:styleDef xmlns:dgm="http://schemas.openxmlformats.org/drawingml/2006/diagram"/>
 </file>
 
@@ -1611,6 +1799,71 @@
       <p:graphicFrame>
         <p:nvGraphicFramePr>
           <p:cNvPr id="3" name="SmartArt 1"/>
+          <p:cNvGraphicFramePr/>
+          <p:nvPr/>
+        </p:nvGraphicFramePr>
+        <p:xfrm>
+          <a:off x="457200" y="680000"/>
+          <a:ext cx="8229600" cy="5744800"/>
+        </p:xfrm>
+        <a:graphic>
+          <a:graphicData uri="http://schemas.openxmlformats.org/drawingml/2006/diagram">
+            <dgm:relIds xmlns:dgm="http://schemas.openxmlformats.org/drawingml/2006/diagram" xmlns:r="http://schemas.openxmlformats.org/officeDocument/2006/relationships" r:dm="rIdDm1" r:lo="rIdLo1" r:qs="rIdQs1" r:cs="rIdCs1"/>
+          </a:graphicData>
+        </a:graphic>
+      </p:graphicFrame>
+    </p:spTree>
+  </p:cSld>
+</p:sld>
+</file>
+
+<file path=ppt/slides/slide10.xml><?xml version="1.0" encoding="utf-8"?>
+<p:sld xmlns:p="http://schemas.openxmlformats.org/presentationml/2006/main" xmlns:a="http://schemas.openxmlformats.org/drawingml/2006/main" xmlns:r="http://schemas.openxmlformats.org/officeDocument/2006/relationships">
+  <p:cSld>
+    <p:spTree>
+      <p:nvGrpSpPr>
+        <p:cNvPr id="1" name=""/>
+        <p:cNvGrpSpPr/>
+        <p:nvPr/>
+      </p:nvGrpSpPr>
+      <p:grpSpPr>
+        <a:xfrm>
+          <a:off x="0" y="0"/>
+          <a:ext cx="0" cy="0"/>
+          <a:chOff x="0" y="0"/>
+          <a:chExt cx="0" cy="0"/>
+        </a:xfrm>
+      </p:grpSpPr>
+      <p:sp>
+        <p:nvSpPr>
+          <p:cNvPr id="2" name="Title"/>
+          <p:cNvSpPr/>
+          <p:nvPr/>
+        </p:nvSpPr>
+        <p:spPr>
+          <a:xfrm>
+            <a:off x="457200" y="130000"/>
+            <a:ext cx="8229600" cy="430000"/>
+          </a:xfrm>
+          <a:prstGeom prst="rect">
+            <a:avLst/>
+          </a:prstGeom>
+          <a:noFill/>
+        </p:spPr>
+        <p:txBody>
+          <a:bodyPr/>
+          <a:lstStyle/>
+          <a:p>
+            <a:r>
+              <a:rPr lang="en-US" sz="1800" b="1"/>
+              <a:t>SmartArt Live - Vertical Arrow List</a:t>
+            </a:r>
+          </a:p>
+        </p:txBody>
+      </p:sp>
+      <p:graphicFrame>
+        <p:nvGraphicFramePr>
+          <p:cNvPr id="3" name="SmartArt 10"/>
           <p:cNvGraphicFramePr/>
           <p:nvPr/>
         </p:nvGraphicFramePr>

</xml_diff>

<commit_message>
FreeP: admit bounded process1 SmartArt cache
</commit_message>
<xml_diff>
--- a/tools/FreeP.RenderCompare/corpus/15-smartart-grouped-list.pptx
+++ b/tools/FreeP.RenderCompare/corpus/15-smartart-grouped-list.pptx
@@ -599,8 +599,235 @@
 </file>
 
 <file path=ppt/diagrams/drawing1.xml><?xml version="1.0" encoding="utf-8"?>
-<dsp:drawing xmlns:dsp="http://schemas.microsoft.com/office/drawing/2008/diagram">
-  <dsp:spTree/>
+<dsp:drawing xmlns:dsp="http://schemas.microsoft.com/office/drawing/2008/diagram" xmlns:a="http://schemas.openxmlformats.org/drawingml/2006/main">
+  <dsp:spTree>
+    <dsp:sp>
+      <dsp:nvSpPr>
+        <dsp:cNvPr id="10" name="Process1 node 1"/>
+        <dsp:cNvSpPr/>
+        <dsp:nvPr/>
+      </dsp:nvSpPr>
+      <dsp:spPr>
+        <a:xfrm>
+          <a:off x="329184" y="689376"/>
+          <a:ext cx="1152144" cy="4366048"/>
+        </a:xfrm>
+        <a:prstGeom prst="roundRect">
+          <a:avLst/>
+        </a:prstGeom>
+        <a:solidFill>
+          <a:srgbClr val="4472C4"/>
+        </a:solidFill>
+        <a:ln/>
+      </dsp:spPr>
+      <dsp:txBody>
+        <a:bodyPr/>
+        <a:lstStyle/>
+        <a:p>
+          <a:r>
+            <a:rPr lang="en-US"/>
+            <a:t>Plan</a:t>
+          </a:r>
+        </a:p>
+      </dsp:txBody>
+    </dsp:sp>
+    <dsp:sp>
+      <dsp:nvSpPr>
+        <dsp:cNvPr id="20" name="Process1 connector 1"/>
+        <dsp:cNvSpPr/>
+        <dsp:nvPr/>
+      </dsp:nvSpPr>
+      <dsp:spPr>
+        <a:xfrm>
+          <a:off x="1584198" y="2872400"/>
+          <a:ext cx="246888" cy="914"/>
+        </a:xfrm>
+        <a:ln>
+          <a:solidFill>
+            <a:srgbClr val="0E4B66"/>
+          </a:solidFill>
+          <a:prstDash val="solid"/>
+        </a:ln>
+      </dsp:spPr>
+    </dsp:sp>
+    <dsp:sp>
+      <dsp:nvSpPr>
+        <dsp:cNvPr id="11" name="Process1 node 2"/>
+        <dsp:cNvSpPr/>
+        <dsp:nvPr/>
+      </dsp:nvSpPr>
+      <dsp:spPr>
+        <a:xfrm>
+          <a:off x="1933956" y="689376"/>
+          <a:ext cx="1152144" cy="4366048"/>
+        </a:xfrm>
+        <a:prstGeom prst="roundRect">
+          <a:avLst/>
+        </a:prstGeom>
+        <a:solidFill>
+          <a:srgbClr val="4472C4"/>
+        </a:solidFill>
+        <a:ln/>
+      </dsp:spPr>
+      <dsp:txBody>
+        <a:bodyPr/>
+        <a:lstStyle/>
+        <a:p>
+          <a:r>
+            <a:rPr lang="en-US"/>
+            <a:t>Design</a:t>
+          </a:r>
+        </a:p>
+      </dsp:txBody>
+    </dsp:sp>
+    <dsp:sp>
+      <dsp:nvSpPr>
+        <dsp:cNvPr id="21" name="Process1 connector 2"/>
+        <dsp:cNvSpPr/>
+        <dsp:nvPr/>
+      </dsp:nvSpPr>
+      <dsp:spPr>
+        <a:xfrm>
+          <a:off x="3188970" y="2872400"/>
+          <a:ext cx="246888" cy="914"/>
+        </a:xfrm>
+        <a:ln>
+          <a:solidFill>
+            <a:srgbClr val="0E4B66"/>
+          </a:solidFill>
+          <a:prstDash val="solid"/>
+        </a:ln>
+      </dsp:spPr>
+    </dsp:sp>
+    <dsp:sp>
+      <dsp:nvSpPr>
+        <dsp:cNvPr id="12" name="Process1 node 3"/>
+        <dsp:cNvSpPr/>
+        <dsp:nvPr/>
+      </dsp:nvSpPr>
+      <dsp:spPr>
+        <a:xfrm>
+          <a:off x="3538728" y="689376"/>
+          <a:ext cx="1152144" cy="4366048"/>
+        </a:xfrm>
+        <a:prstGeom prst="roundRect">
+          <a:avLst/>
+        </a:prstGeom>
+        <a:solidFill>
+          <a:srgbClr val="4472C4"/>
+        </a:solidFill>
+        <a:ln/>
+      </dsp:spPr>
+      <dsp:txBody>
+        <a:bodyPr/>
+        <a:lstStyle/>
+        <a:p>
+          <a:r>
+            <a:rPr lang="en-US"/>
+            <a:t>Build</a:t>
+          </a:r>
+        </a:p>
+      </dsp:txBody>
+    </dsp:sp>
+    <dsp:sp>
+      <dsp:nvSpPr>
+        <dsp:cNvPr id="22" name="Process1 connector 3"/>
+        <dsp:cNvSpPr/>
+        <dsp:nvPr/>
+      </dsp:nvSpPr>
+      <dsp:spPr>
+        <a:xfrm>
+          <a:off x="4793742" y="2872400"/>
+          <a:ext cx="246888" cy="914"/>
+        </a:xfrm>
+        <a:ln>
+          <a:solidFill>
+            <a:srgbClr val="0E4B66"/>
+          </a:solidFill>
+          <a:prstDash val="solid"/>
+        </a:ln>
+      </dsp:spPr>
+    </dsp:sp>
+    <dsp:sp>
+      <dsp:nvSpPr>
+        <dsp:cNvPr id="13" name="Process1 node 4"/>
+        <dsp:cNvSpPr/>
+        <dsp:nvPr/>
+      </dsp:nvSpPr>
+      <dsp:spPr>
+        <a:xfrm>
+          <a:off x="5143500" y="689376"/>
+          <a:ext cx="1152144" cy="4366048"/>
+        </a:xfrm>
+        <a:prstGeom prst="roundRect">
+          <a:avLst/>
+        </a:prstGeom>
+        <a:solidFill>
+          <a:srgbClr val="4472C4"/>
+        </a:solidFill>
+        <a:ln/>
+      </dsp:spPr>
+      <dsp:txBody>
+        <a:bodyPr/>
+        <a:lstStyle/>
+        <a:p>
+          <a:r>
+            <a:rPr lang="en-US"/>
+            <a:t>Test</a:t>
+          </a:r>
+        </a:p>
+      </dsp:txBody>
+    </dsp:sp>
+    <dsp:sp>
+      <dsp:nvSpPr>
+        <dsp:cNvPr id="23" name="Process1 connector 4"/>
+        <dsp:cNvSpPr/>
+        <dsp:nvPr/>
+      </dsp:nvSpPr>
+      <dsp:spPr>
+        <a:xfrm>
+          <a:off x="6398514" y="2872400"/>
+          <a:ext cx="246888" cy="914"/>
+        </a:xfrm>
+        <a:ln>
+          <a:solidFill>
+            <a:srgbClr val="0E4B66"/>
+          </a:solidFill>
+          <a:prstDash val="solid"/>
+        </a:ln>
+      </dsp:spPr>
+    </dsp:sp>
+    <dsp:sp>
+      <dsp:nvSpPr>
+        <dsp:cNvPr id="14" name="Process1 node 5"/>
+        <dsp:cNvSpPr/>
+        <dsp:nvPr/>
+      </dsp:nvSpPr>
+      <dsp:spPr>
+        <a:xfrm>
+          <a:off x="6748272" y="689376"/>
+          <a:ext cx="1152144" cy="4366048"/>
+        </a:xfrm>
+        <a:prstGeom prst="roundRect">
+          <a:avLst/>
+        </a:prstGeom>
+        <a:solidFill>
+          <a:srgbClr val="4472C4"/>
+        </a:solidFill>
+        <a:ln/>
+      </dsp:spPr>
+      <dsp:txBody>
+        <a:bodyPr/>
+        <a:lstStyle/>
+        <a:p>
+          <a:r>
+            <a:rPr lang="en-US"/>
+            <a:t>Deploy</a:t>
+          </a:r>
+        </a:p>
+      </dsp:txBody>
+    </dsp:sp>
+  </dsp:spTree>
 </dsp:drawing>
 </file>
 

</xml_diff>

<commit_message>
FreeP: admit bounded list1 SmartArt cache
</commit_message>
<xml_diff>
--- a/tools/FreeP.RenderCompare/corpus/15-smartart-grouped-list.pptx
+++ b/tools/FreeP.RenderCompare/corpus/15-smartart-grouped-list.pptx
@@ -1214,8 +1214,129 @@
 </file>
 
 <file path=ppt/diagrams/drawing5.xml><?xml version="1.0" encoding="utf-8"?>
-<dsp:drawing xmlns:dsp="http://schemas.microsoft.com/office/drawing/2008/diagram">
-  <dsp:spTree/>
+<dsp:drawing xmlns:dsp="http://schemas.microsoft.com/office/drawing/2008/diagram" xmlns:a="http://schemas.openxmlformats.org/drawingml/2006/main">
+  <dsp:spTree>
+    <dsp:sp>
+      <dsp:nvSpPr>
+        <dsp:cNvPr id="120" name="List1 node 1"/>
+        <dsp:cNvSpPr/>
+        <dsp:nvPr/>
+      </dsp:nvSpPr>
+      <dsp:spPr>
+        <a:xfrm>
+          <a:off x="329184" y="229792"/>
+          <a:ext cx="7571232" cy="1213589"/>
+        </a:xfrm>
+        <a:prstGeom prst="roundRect">
+          <a:avLst/>
+        </a:prstGeom>
+        <a:solidFill>
+          <a:srgbClr val="4472C4"/>
+        </a:solidFill>
+        <a:ln/>
+      </dsp:spPr>
+      <dsp:txBody>
+        <a:bodyPr/>
+        <a:lstStyle/>
+        <a:p>
+          <a:r>
+            <a:rPr lang="en-US"/>
+            <a:t>Requirement 1</a:t>
+          </a:r>
+        </a:p>
+      </dsp:txBody>
+    </dsp:sp>
+    <dsp:sp>
+      <dsp:nvSpPr>
+        <dsp:cNvPr id="121" name="List1 node 2"/>
+        <dsp:cNvSpPr/>
+        <dsp:nvPr/>
+      </dsp:nvSpPr>
+      <dsp:spPr>
+        <a:xfrm>
+          <a:off x="329184" y="1587001"/>
+          <a:ext cx="7571232" cy="1213589"/>
+        </a:xfrm>
+        <a:prstGeom prst="roundRect">
+          <a:avLst/>
+        </a:prstGeom>
+        <a:solidFill>
+          <a:srgbClr val="4472C4"/>
+        </a:solidFill>
+        <a:ln/>
+      </dsp:spPr>
+      <dsp:txBody>
+        <a:bodyPr/>
+        <a:lstStyle/>
+        <a:p>
+          <a:r>
+            <a:rPr lang="en-US"/>
+            <a:t>Requirement 2</a:t>
+          </a:r>
+        </a:p>
+      </dsp:txBody>
+    </dsp:sp>
+    <dsp:sp>
+      <dsp:nvSpPr>
+        <dsp:cNvPr id="122" name="List1 node 3"/>
+        <dsp:cNvSpPr/>
+        <dsp:nvPr/>
+      </dsp:nvSpPr>
+      <dsp:spPr>
+        <a:xfrm>
+          <a:off x="329184" y="2944210"/>
+          <a:ext cx="7571232" cy="1213589"/>
+        </a:xfrm>
+        <a:prstGeom prst="roundRect">
+          <a:avLst/>
+        </a:prstGeom>
+        <a:solidFill>
+          <a:srgbClr val="4472C4"/>
+        </a:solidFill>
+        <a:ln/>
+      </dsp:spPr>
+      <dsp:txBody>
+        <a:bodyPr/>
+        <a:lstStyle/>
+        <a:p>
+          <a:r>
+            <a:rPr lang="en-US"/>
+            <a:t>Requirement 3</a:t>
+          </a:r>
+        </a:p>
+      </dsp:txBody>
+    </dsp:sp>
+    <dsp:sp>
+      <dsp:nvSpPr>
+        <dsp:cNvPr id="123" name="List1 node 4"/>
+        <dsp:cNvSpPr/>
+        <dsp:nvPr/>
+      </dsp:nvSpPr>
+      <dsp:spPr>
+        <a:xfrm>
+          <a:off x="329184" y="4301419"/>
+          <a:ext cx="7571232" cy="1213589"/>
+        </a:xfrm>
+        <a:prstGeom prst="roundRect">
+          <a:avLst/>
+        </a:prstGeom>
+        <a:solidFill>
+          <a:srgbClr val="4472C4"/>
+        </a:solidFill>
+        <a:ln/>
+      </dsp:spPr>
+      <dsp:txBody>
+        <a:bodyPr/>
+        <a:lstStyle/>
+        <a:p>
+          <a:r>
+            <a:rPr lang="en-US"/>
+            <a:t>Requirement 4</a:t>
+          </a:r>
+        </a:p>
+      </dsp:txBody>
+    </dsp:sp>
+  </dsp:spTree>
 </dsp:drawing>
 </file>
 

</xml_diff>

<commit_message>
FreeP: make SmartArt corpus PowerPoint-openable
</commit_message>
<xml_diff>
--- a/tools/FreeP.RenderCompare/corpus/15-smartart-grouped-list.pptx
+++ b/tools/FreeP.RenderCompare/corpus/15-smartart-grouped-list.pptx
@@ -18,6 +18,14 @@
   </p:sldIdLst>
   <p:sldSz cx="9144000" cy="6858000"/>
   <p:notesSz cx="6858000" cy="9144000"/>
+  <p:defaultTextStyle>
+    <a:defPPr>
+      <a:defRPr lang="en-US"/>
+    </a:defPPr>
+    <a:lvl1pPr marL="0" algn="l" defTabSz="914400">
+      <a:defRPr sz="1800"/>
+    </a:lvl1pPr>
+  </p:defaultTextStyle>
   <p:extLst>
     <p:ext uri="{EFAFB233-063F-42B5-8137-9DF3F51BA10A}">
       <p15:sldGuideLst/>
@@ -27,50 +35,65 @@
 </file>
 
 <file path=ppt/diagrams/colors1.xml><?xml version="1.0" encoding="utf-8"?>
-<dgm:colorsDef xmlns:dgm="http://schemas.openxmlformats.org/drawingml/2006/diagram"/>
+<dgm:colorsDef xmlns:dgm="http://schemas.openxmlformats.org/drawingml/2006/diagram" xmlns:a="http://schemas.openxmlformats.org/drawingml/2006/main"/>
 </file>
 
 <file path=ppt/diagrams/colors10.xml><?xml version="1.0" encoding="utf-8"?>
-<dgm:colorsDef xmlns:dgm="http://schemas.openxmlformats.org/drawingml/2006/diagram"/>
+<dgm:colorsDef xmlns:dgm="http://schemas.openxmlformats.org/drawingml/2006/diagram" xmlns:a="http://schemas.openxmlformats.org/drawingml/2006/main"/>
 </file>
 
 <file path=ppt/diagrams/colors2.xml><?xml version="1.0" encoding="utf-8"?>
-<dgm:colorsDef xmlns:dgm="http://schemas.openxmlformats.org/drawingml/2006/diagram"/>
+<dgm:colorsDef xmlns:dgm="http://schemas.openxmlformats.org/drawingml/2006/diagram" xmlns:a="http://schemas.openxmlformats.org/drawingml/2006/main"/>
 </file>
 
 <file path=ppt/diagrams/colors3.xml><?xml version="1.0" encoding="utf-8"?>
-<dgm:colorsDef xmlns:dgm="http://schemas.openxmlformats.org/drawingml/2006/diagram"/>
+<dgm:colorsDef xmlns:dgm="http://schemas.openxmlformats.org/drawingml/2006/diagram" xmlns:a="http://schemas.openxmlformats.org/drawingml/2006/main"/>
 </file>
 
 <file path=ppt/diagrams/colors4.xml><?xml version="1.0" encoding="utf-8"?>
-<dgm:colorsDef xmlns:dgm="http://schemas.openxmlformats.org/drawingml/2006/diagram"/>
+<dgm:colorsDef xmlns:dgm="http://schemas.openxmlformats.org/drawingml/2006/diagram" xmlns:a="http://schemas.openxmlformats.org/drawingml/2006/main"/>
 </file>
 
 <file path=ppt/diagrams/colors5.xml><?xml version="1.0" encoding="utf-8"?>
-<dgm:colorsDef xmlns:dgm="http://schemas.openxmlformats.org/drawingml/2006/diagram"/>
+<dgm:colorsDef xmlns:dgm="http://schemas.openxmlformats.org/drawingml/2006/diagram" xmlns:a="http://schemas.openxmlformats.org/drawingml/2006/main"/>
 </file>
 
 <file path=ppt/diagrams/colors6.xml><?xml version="1.0" encoding="utf-8"?>
-<dgm:colorsDef xmlns:dgm="http://schemas.openxmlformats.org/drawingml/2006/diagram"/>
+<dgm:colorsDef xmlns:dgm="http://schemas.openxmlformats.org/drawingml/2006/diagram" xmlns:a="http://schemas.openxmlformats.org/drawingml/2006/main"/>
 </file>
 
 <file path=ppt/diagrams/colors7.xml><?xml version="1.0" encoding="utf-8"?>
-<dgm:colorsDef xmlns:dgm="http://schemas.openxmlformats.org/drawingml/2006/diagram"/>
+<dgm:colorsDef xmlns:dgm="http://schemas.openxmlformats.org/drawingml/2006/diagram" xmlns:a="http://schemas.openxmlformats.org/drawingml/2006/main"/>
 </file>
 
 <file path=ppt/diagrams/colors8.xml><?xml version="1.0" encoding="utf-8"?>
-<dgm:colorsDef xmlns:dgm="http://schemas.openxmlformats.org/drawingml/2006/diagram"/>
+<dgm:colorsDef xmlns:dgm="http://schemas.openxmlformats.org/drawingml/2006/diagram" xmlns:a="http://schemas.openxmlformats.org/drawingml/2006/main"/>
 </file>
 
 <file path=ppt/diagrams/colors9.xml><?xml version="1.0" encoding="utf-8"?>
-<dgm:colorsDef xmlns:dgm="http://schemas.openxmlformats.org/drawingml/2006/diagram"/>
+<dgm:colorsDef xmlns:dgm="http://schemas.openxmlformats.org/drawingml/2006/diagram" xmlns:a="http://schemas.openxmlformats.org/drawingml/2006/main"/>
 </file>
 
 <file path=ppt/diagrams/data1.xml><?xml version="1.0" encoding="utf-8"?>
 <dgm:dataModel xmlns:dgm="http://schemas.openxmlformats.org/drawingml/2006/diagram" xmlns:a="http://schemas.openxmlformats.org/drawingml/2006/main">
   <dgm:ptLst>
-    <dgm:pt modelId="n1" type="node">
-      <dgm:t>
+    <dgm:pt modelId="{D2FBFA5C-1EB7-71CC-DCA7-AA1A87A97C0A}" type="doc">
+      <dgm:prSet loTypeId="urn:microsoft.com/office/officeart/2005/8/layout/process1" loCatId="list" qsTypeId="urn:microsoft.com/office/officeart/2005/8/quickstyle/simple1" qsCatId="simple" csTypeId="urn:microsoft.com/office/officeart/2005/8/colors/accent1_2" csCatId="accent1" phldr="1"/>
+      <dgm:spPr/>
+      <dgm:t>
+        <a:bodyPr/>
+        <a:lstStyle/>
+        <a:p>
+          <a:endParaRPr lang="en-US"/>
+        </a:p>
+      </dgm:t>
+    </dgm:pt>
+    <dgm:pt modelId="{B88B6B67-E74C-7D26-D520-DECA4811C8F1}">
+      <dgm:prSet phldrT="[Text]"/>
+      <dgm:spPr/>
+      <dgm:t>
+        <a:bodyPr/>
+        <a:lstStyle/>
         <a:p>
           <a:r>
             <a:rPr lang="en-US"/>
@@ -79,8 +102,12 @@
         </a:p>
       </dgm:t>
     </dgm:pt>
-    <dgm:pt modelId="n2" type="node">
-      <dgm:t>
+    <dgm:pt modelId="{3DA98004-9B2E-4B09-89E0-8E01976089AC}">
+      <dgm:prSet phldrT="[Text]"/>
+      <dgm:spPr/>
+      <dgm:t>
+        <a:bodyPr/>
+        <a:lstStyle/>
         <a:p>
           <a:r>
             <a:rPr lang="en-US"/>
@@ -89,8 +116,12 @@
         </a:p>
       </dgm:t>
     </dgm:pt>
-    <dgm:pt modelId="n3" type="node">
-      <dgm:t>
+    <dgm:pt modelId="{64D62187-60EF-6A09-A559-E1AA6C72CAF1}">
+      <dgm:prSet phldrT="[Text]"/>
+      <dgm:spPr/>
+      <dgm:t>
+        <a:bodyPr/>
+        <a:lstStyle/>
         <a:p>
           <a:r>
             <a:rPr lang="en-US"/>
@@ -99,8 +130,12 @@
         </a:p>
       </dgm:t>
     </dgm:pt>
-    <dgm:pt modelId="n4" type="node">
-      <dgm:t>
+    <dgm:pt modelId="{080B4588-C42E-2FDF-DCCD-3A626C6E489B}">
+      <dgm:prSet phldrT="[Text]"/>
+      <dgm:spPr/>
+      <dgm:t>
+        <a:bodyPr/>
+        <a:lstStyle/>
         <a:p>
           <a:r>
             <a:rPr lang="en-US"/>
@@ -109,8 +144,12 @@
         </a:p>
       </dgm:t>
     </dgm:pt>
-    <dgm:pt modelId="n5" type="node">
-      <dgm:t>
+    <dgm:pt modelId="{F156844A-370E-9768-78CE-F532AB6A7374}">
+      <dgm:prSet phldrT="[Text]"/>
+      <dgm:spPr/>
+      <dgm:t>
+        <a:bodyPr/>
+        <a:lstStyle/>
         <a:p>
           <a:r>
             <a:rPr lang="en-US"/>
@@ -121,19 +160,37 @@
     </dgm:pt>
   </dgm:ptLst>
   <dgm:cxnLst>
-    <dgm:cxn type="parOf" srcId="n1" destId="n2"/>
-    <dgm:cxn type="parOf" srcId="n2" destId="n3"/>
-    <dgm:cxn type="parOf" srcId="n3" destId="n4"/>
-    <dgm:cxn type="parOf" srcId="n4" destId="n5"/>
+    <dgm:cxn modelId="{00055647-65B1-719A-6302-3B19C0CB9B70}" type="parOf" srcId="{B88B6B67-E74C-7D26-D520-DECA4811C8F1}" destId="{3DA98004-9B2E-4B09-89E0-8E01976089AC}" srcOrd="0" destOrd="0"/>
+    <dgm:cxn modelId="{3FCAF11C-53CD-6386-A616-3ECD6E4BB444}" type="parOf" srcId="{3DA98004-9B2E-4B09-89E0-8E01976089AC}" destId="{64D62187-60EF-6A09-A559-E1AA6C72CAF1}" srcOrd="1" destOrd="1"/>
+    <dgm:cxn modelId="{2D9D9A3E-CB12-7559-1A02-ED32C36F370E}" type="parOf" srcId="{64D62187-60EF-6A09-A559-E1AA6C72CAF1}" destId="{080B4588-C42E-2FDF-DCCD-3A626C6E489B}" srcOrd="2" destOrd="2"/>
+    <dgm:cxn modelId="{DA32110D-3237-9C19-934F-4099D6DA8E6A}" type="parOf" srcId="{080B4588-C42E-2FDF-DCCD-3A626C6E489B}" destId="{F156844A-370E-9768-78CE-F532AB6A7374}" srcOrd="3" destOrd="3"/>
   </dgm:cxnLst>
+  <dgm:bg/>
+  <dgm:whole/>
+  <dgm:extLst/>
 </dgm:dataModel>
 </file>
 
 <file path=ppt/diagrams/data10.xml><?xml version="1.0" encoding="utf-8"?>
 <dgm:dataModel xmlns:dgm="http://schemas.openxmlformats.org/drawingml/2006/diagram" xmlns:a="http://schemas.openxmlformats.org/drawingml/2006/main">
   <dgm:ptLst>
-    <dgm:pt modelId="va1" type="node">
-      <dgm:t>
+    <dgm:pt modelId="{1865C683-E4DE-39B4-E6B0-CEE312840EEC}" type="doc">
+      <dgm:prSet loTypeId="urn:microsoft.com/office/officeart/2005/8/layout/verticalArrowList" loCatId="list" qsTypeId="urn:microsoft.com/office/officeart/2005/8/quickstyle/simple1" qsCatId="simple" csTypeId="urn:microsoft.com/office/officeart/2005/8/colors/accent1_2" csCatId="accent1" phldr="1"/>
+      <dgm:spPr/>
+      <dgm:t>
+        <a:bodyPr/>
+        <a:lstStyle/>
+        <a:p>
+          <a:endParaRPr lang="en-US"/>
+        </a:p>
+      </dgm:t>
+    </dgm:pt>
+    <dgm:pt modelId="{248C4E91-B4E1-2C77-A66A-E9FACC1DEDDD}">
+      <dgm:prSet phldrT="[Text]"/>
+      <dgm:spPr/>
+      <dgm:t>
+        <a:bodyPr/>
+        <a:lstStyle/>
         <a:p>
           <a:r>
             <a:rPr lang="en-US"/>
@@ -142,8 +199,12 @@
         </a:p>
       </dgm:t>
     </dgm:pt>
-    <dgm:pt modelId="va2" type="node">
-      <dgm:t>
+    <dgm:pt modelId="{B4F7D8B0-F0DE-15C7-A4F1-C3102F2F9AAD}">
+      <dgm:prSet phldrT="[Text]"/>
+      <dgm:spPr/>
+      <dgm:t>
+        <a:bodyPr/>
+        <a:lstStyle/>
         <a:p>
           <a:r>
             <a:rPr lang="en-US"/>
@@ -152,8 +213,12 @@
         </a:p>
       </dgm:t>
     </dgm:pt>
-    <dgm:pt modelId="va3" type="node">
-      <dgm:t>
+    <dgm:pt modelId="{18AEACAF-55A8-C871-B379-3B9FFA325184}">
+      <dgm:prSet phldrT="[Text]"/>
+      <dgm:spPr/>
+      <dgm:t>
+        <a:bodyPr/>
+        <a:lstStyle/>
         <a:p>
           <a:r>
             <a:rPr lang="en-US"/>
@@ -162,8 +227,12 @@
         </a:p>
       </dgm:t>
     </dgm:pt>
-    <dgm:pt modelId="va4" type="node">
-      <dgm:t>
+    <dgm:pt modelId="{125D0151-4FE4-0902-D7DC-F1355305DDD2}">
+      <dgm:prSet phldrT="[Text]"/>
+      <dgm:spPr/>
+      <dgm:t>
+        <a:bodyPr/>
+        <a:lstStyle/>
         <a:p>
           <a:r>
             <a:rPr lang="en-US"/>
@@ -174,14 +243,32 @@
     </dgm:pt>
   </dgm:ptLst>
   <dgm:cxnLst/>
+  <dgm:bg/>
+  <dgm:whole/>
+  <dgm:extLst/>
 </dgm:dataModel>
 </file>
 
 <file path=ppt/diagrams/data2.xml><?xml version="1.0" encoding="utf-8"?>
 <dgm:dataModel xmlns:dgm="http://schemas.openxmlformats.org/drawingml/2006/diagram" xmlns:a="http://schemas.openxmlformats.org/drawingml/2006/main">
   <dgm:ptLst>
-    <dgm:pt modelId="r" type="node">
-      <dgm:t>
+    <dgm:pt modelId="{2B1A54B9-0858-4991-0781-CE65CE84CC16}" type="doc">
+      <dgm:prSet loTypeId="urn:microsoft.com/office/officeart/2005/8/layout/hierarchy1" loCatId="list" qsTypeId="urn:microsoft.com/office/officeart/2005/8/quickstyle/simple1" qsCatId="simple" csTypeId="urn:microsoft.com/office/officeart/2005/8/colors/accent1_2" csCatId="accent1" phldr="1"/>
+      <dgm:spPr/>
+      <dgm:t>
+        <a:bodyPr/>
+        <a:lstStyle/>
+        <a:p>
+          <a:endParaRPr lang="en-US"/>
+        </a:p>
+      </dgm:t>
+    </dgm:pt>
+    <dgm:pt modelId="{E4494345-F022-9752-191E-AD13E21D3DB5}">
+      <dgm:prSet phldrT="[Text]"/>
+      <dgm:spPr/>
+      <dgm:t>
+        <a:bodyPr/>
+        <a:lstStyle/>
         <a:p>
           <a:r>
             <a:rPr lang="en-US"/>
@@ -190,8 +277,12 @@
         </a:p>
       </dgm:t>
     </dgm:pt>
-    <dgm:pt modelId="c1" type="node">
-      <dgm:t>
+    <dgm:pt modelId="{CA31F6D0-DB1D-DBA8-3BCF-CB9E057CDC98}">
+      <dgm:prSet phldrT="[Text]"/>
+      <dgm:spPr/>
+      <dgm:t>
+        <a:bodyPr/>
+        <a:lstStyle/>
         <a:p>
           <a:r>
             <a:rPr lang="en-US"/>
@@ -200,8 +291,12 @@
         </a:p>
       </dgm:t>
     </dgm:pt>
-    <dgm:pt modelId="c2" type="node">
-      <dgm:t>
+    <dgm:pt modelId="{51BE0A9C-E6C6-5D65-81DE-2D044D4FB194}">
+      <dgm:prSet phldrT="[Text]"/>
+      <dgm:spPr/>
+      <dgm:t>
+        <a:bodyPr/>
+        <a:lstStyle/>
         <a:p>
           <a:r>
             <a:rPr lang="en-US"/>
@@ -210,8 +305,12 @@
         </a:p>
       </dgm:t>
     </dgm:pt>
-    <dgm:pt modelId="c3" type="node">
-      <dgm:t>
+    <dgm:pt modelId="{DF971C7C-C017-9266-4822-B0AF09A65251}">
+      <dgm:prSet phldrT="[Text]"/>
+      <dgm:spPr/>
+      <dgm:t>
+        <a:bodyPr/>
+        <a:lstStyle/>
         <a:p>
           <a:r>
             <a:rPr lang="en-US"/>
@@ -222,18 +321,36 @@
     </dgm:pt>
   </dgm:ptLst>
   <dgm:cxnLst>
-    <dgm:cxn type="parOf" srcId="r" destId="c1"/>
-    <dgm:cxn type="parOf" srcId="r" destId="c2"/>
-    <dgm:cxn type="parOf" srcId="r" destId="c3"/>
+    <dgm:cxn modelId="{FED7BB39-B972-9CDF-6B82-965FA8492377}" type="parOf" srcId="{E4494345-F022-9752-191E-AD13E21D3DB5}" destId="{CA31F6D0-DB1D-DBA8-3BCF-CB9E057CDC98}" srcOrd="0" destOrd="0"/>
+    <dgm:cxn modelId="{77DC05ED-A301-4561-1E52-BE68630C0450}" type="parOf" srcId="{E4494345-F022-9752-191E-AD13E21D3DB5}" destId="{51BE0A9C-E6C6-5D65-81DE-2D044D4FB194}" srcOrd="1" destOrd="1"/>
+    <dgm:cxn modelId="{964789A7-BA68-CCB7-EF55-626A23AC2A2A}" type="parOf" srcId="{E4494345-F022-9752-191E-AD13E21D3DB5}" destId="{DF971C7C-C017-9266-4822-B0AF09A65251}" srcOrd="2" destOrd="2"/>
   </dgm:cxnLst>
+  <dgm:bg/>
+  <dgm:whole/>
+  <dgm:extLst/>
 </dgm:dataModel>
 </file>
 
 <file path=ppt/diagrams/data3.xml><?xml version="1.0" encoding="utf-8"?>
 <dgm:dataModel xmlns:dgm="http://schemas.openxmlformats.org/drawingml/2006/diagram" xmlns:a="http://schemas.openxmlformats.org/drawingml/2006/main">
   <dgm:ptLst>
-    <dgm:pt modelId="r" type="node">
-      <dgm:t>
+    <dgm:pt modelId="{FE166D3A-1C78-84F7-7670-324A8737FBEC}" type="doc">
+      <dgm:prSet loTypeId="urn:microsoft.com/office/officeart/2005/8/layout/hierarchy3" loCatId="list" qsTypeId="urn:microsoft.com/office/officeart/2005/8/quickstyle/simple1" qsCatId="simple" csTypeId="urn:microsoft.com/office/officeart/2005/8/colors/accent1_2" csCatId="accent1" phldr="1"/>
+      <dgm:spPr/>
+      <dgm:t>
+        <a:bodyPr/>
+        <a:lstStyle/>
+        <a:p>
+          <a:endParaRPr lang="en-US"/>
+        </a:p>
+      </dgm:t>
+    </dgm:pt>
+    <dgm:pt modelId="{E4494345-F022-9752-191E-AD13E21D3DB5}">
+      <dgm:prSet phldrT="[Text]"/>
+      <dgm:spPr/>
+      <dgm:t>
+        <a:bodyPr/>
+        <a:lstStyle/>
         <a:p>
           <a:r>
             <a:rPr lang="en-US"/>
@@ -242,8 +359,12 @@
         </a:p>
       </dgm:t>
     </dgm:pt>
-    <dgm:pt modelId="c1" type="node">
-      <dgm:t>
+    <dgm:pt modelId="{CA31F6D0-DB1D-DBA8-3BCF-CB9E057CDC98}">
+      <dgm:prSet phldrT="[Text]"/>
+      <dgm:spPr/>
+      <dgm:t>
+        <a:bodyPr/>
+        <a:lstStyle/>
         <a:p>
           <a:r>
             <a:rPr lang="en-US"/>
@@ -252,8 +373,12 @@
         </a:p>
       </dgm:t>
     </dgm:pt>
-    <dgm:pt modelId="c2" type="node">
-      <dgm:t>
+    <dgm:pt modelId="{51BE0A9C-E6C6-5D65-81DE-2D044D4FB194}">
+      <dgm:prSet phldrT="[Text]"/>
+      <dgm:spPr/>
+      <dgm:t>
+        <a:bodyPr/>
+        <a:lstStyle/>
         <a:p>
           <a:r>
             <a:rPr lang="en-US"/>
@@ -262,8 +387,12 @@
         </a:p>
       </dgm:t>
     </dgm:pt>
-    <dgm:pt modelId="c3" type="node">
-      <dgm:t>
+    <dgm:pt modelId="{DF971C7C-C017-9266-4822-B0AF09A65251}">
+      <dgm:prSet phldrT="[Text]"/>
+      <dgm:spPr/>
+      <dgm:t>
+        <a:bodyPr/>
+        <a:lstStyle/>
         <a:p>
           <a:r>
             <a:rPr lang="en-US"/>
@@ -274,18 +403,36 @@
     </dgm:pt>
   </dgm:ptLst>
   <dgm:cxnLst>
-    <dgm:cxn type="parOf" srcId="r" destId="c1"/>
-    <dgm:cxn type="parOf" srcId="r" destId="c2"/>
-    <dgm:cxn type="parOf" srcId="r" destId="c3"/>
+    <dgm:cxn modelId="{FED7BB39-B972-9CDF-6B82-965FA8492377}" type="parOf" srcId="{E4494345-F022-9752-191E-AD13E21D3DB5}" destId="{CA31F6D0-DB1D-DBA8-3BCF-CB9E057CDC98}" srcOrd="0" destOrd="0"/>
+    <dgm:cxn modelId="{77DC05ED-A301-4561-1E52-BE68630C0450}" type="parOf" srcId="{E4494345-F022-9752-191E-AD13E21D3DB5}" destId="{51BE0A9C-E6C6-5D65-81DE-2D044D4FB194}" srcOrd="1" destOrd="1"/>
+    <dgm:cxn modelId="{964789A7-BA68-CCB7-EF55-626A23AC2A2A}" type="parOf" srcId="{E4494345-F022-9752-191E-AD13E21D3DB5}" destId="{DF971C7C-C017-9266-4822-B0AF09A65251}" srcOrd="2" destOrd="2"/>
   </dgm:cxnLst>
+  <dgm:bg/>
+  <dgm:whole/>
+  <dgm:extLst/>
 </dgm:dataModel>
 </file>
 
 <file path=ppt/diagrams/data4.xml><?xml version="1.0" encoding="utf-8"?>
 <dgm:dataModel xmlns:dgm="http://schemas.openxmlformats.org/drawingml/2006/diagram" xmlns:a="http://schemas.openxmlformats.org/drawingml/2006/main">
   <dgm:ptLst>
-    <dgm:pt modelId="a" type="node">
-      <dgm:t>
+    <dgm:pt modelId="{49BA1802-C0FD-C246-9E33-2DB5BCB04957}" type="doc">
+      <dgm:prSet loTypeId="urn:microsoft.com/office/officeart/2005/8/layout/cycle1" loCatId="list" qsTypeId="urn:microsoft.com/office/officeart/2005/8/quickstyle/simple1" qsCatId="simple" csTypeId="urn:microsoft.com/office/officeart/2005/8/colors/accent1_2" csCatId="accent1" phldr="1"/>
+      <dgm:spPr/>
+      <dgm:t>
+        <a:bodyPr/>
+        <a:lstStyle/>
+        <a:p>
+          <a:endParaRPr lang="en-US"/>
+        </a:p>
+      </dgm:t>
+    </dgm:pt>
+    <dgm:pt modelId="{128197CA-1BCA-CABD-FAC2-31B39A23DC4D}">
+      <dgm:prSet phldrT="[Text]"/>
+      <dgm:spPr/>
+      <dgm:t>
+        <a:bodyPr/>
+        <a:lstStyle/>
         <a:p>
           <a:r>
             <a:rPr lang="en-US"/>
@@ -294,8 +441,12 @@
         </a:p>
       </dgm:t>
     </dgm:pt>
-    <dgm:pt modelId="b" type="node">
-      <dgm:t>
+    <dgm:pt modelId="{16E8233E-3900-4A59-3389-4F6564E1B134}">
+      <dgm:prSet phldrT="[Text]"/>
+      <dgm:spPr/>
+      <dgm:t>
+        <a:bodyPr/>
+        <a:lstStyle/>
         <a:p>
           <a:r>
             <a:rPr lang="en-US"/>
@@ -304,8 +455,12 @@
         </a:p>
       </dgm:t>
     </dgm:pt>
-    <dgm:pt modelId="c" type="node">
-      <dgm:t>
+    <dgm:pt modelId="{032C7D2E-50A9-E27A-65EC-F5B5356885A5}">
+      <dgm:prSet phldrT="[Text]"/>
+      <dgm:spPr/>
+      <dgm:t>
+        <a:bodyPr/>
+        <a:lstStyle/>
         <a:p>
           <a:r>
             <a:rPr lang="en-US"/>
@@ -314,8 +469,12 @@
         </a:p>
       </dgm:t>
     </dgm:pt>
-    <dgm:pt modelId="d" type="node">
-      <dgm:t>
+    <dgm:pt modelId="{733EAC18-F043-8916-0C51-0E93F9352611}">
+      <dgm:prSet phldrT="[Text]"/>
+      <dgm:spPr/>
+      <dgm:t>
+        <a:bodyPr/>
+        <a:lstStyle/>
         <a:p>
           <a:r>
             <a:rPr lang="en-US"/>
@@ -324,8 +483,12 @@
         </a:p>
       </dgm:t>
     </dgm:pt>
-    <dgm:pt modelId="e" type="node">
-      <dgm:t>
+    <dgm:pt modelId="{7BBB793F-5B43-3205-1651-DAEFD374CDC6}">
+      <dgm:prSet phldrT="[Text]"/>
+      <dgm:spPr/>
+      <dgm:t>
+        <a:bodyPr/>
+        <a:lstStyle/>
         <a:p>
           <a:r>
             <a:rPr lang="en-US"/>
@@ -336,14 +499,32 @@
     </dgm:pt>
   </dgm:ptLst>
   <dgm:cxnLst/>
+  <dgm:bg/>
+  <dgm:whole/>
+  <dgm:extLst/>
 </dgm:dataModel>
 </file>
 
 <file path=ppt/diagrams/data5.xml><?xml version="1.0" encoding="utf-8"?>
 <dgm:dataModel xmlns:dgm="http://schemas.openxmlformats.org/drawingml/2006/diagram" xmlns:a="http://schemas.openxmlformats.org/drawingml/2006/main">
   <dgm:ptLst>
-    <dgm:pt modelId="i1" type="node">
-      <dgm:t>
+    <dgm:pt modelId="{2724C83D-5E50-DA47-D369-F79C05E12699}" type="doc">
+      <dgm:prSet loTypeId="urn:microsoft.com/office/officeart/2005/8/layout/list1" loCatId="list" qsTypeId="urn:microsoft.com/office/officeart/2005/8/quickstyle/simple1" qsCatId="simple" csTypeId="urn:microsoft.com/office/officeart/2005/8/colors/accent1_2" csCatId="accent1" phldr="1"/>
+      <dgm:spPr/>
+      <dgm:t>
+        <a:bodyPr/>
+        <a:lstStyle/>
+        <a:p>
+          <a:endParaRPr lang="en-US"/>
+        </a:p>
+      </dgm:t>
+    </dgm:pt>
+    <dgm:pt modelId="{67B7D94C-7F2D-E8BE-FB51-FB1E049F6903}">
+      <dgm:prSet phldrT="[Text]"/>
+      <dgm:spPr/>
+      <dgm:t>
+        <a:bodyPr/>
+        <a:lstStyle/>
         <a:p>
           <a:r>
             <a:rPr lang="en-US"/>
@@ -352,8 +533,12 @@
         </a:p>
       </dgm:t>
     </dgm:pt>
-    <dgm:pt modelId="i2" type="node">
-      <dgm:t>
+    <dgm:pt modelId="{31CE0F42-7541-40DF-2ADB-EAE3CFBBB856}">
+      <dgm:prSet phldrT="[Text]"/>
+      <dgm:spPr/>
+      <dgm:t>
+        <a:bodyPr/>
+        <a:lstStyle/>
         <a:p>
           <a:r>
             <a:rPr lang="en-US"/>
@@ -362,8 +547,12 @@
         </a:p>
       </dgm:t>
     </dgm:pt>
-    <dgm:pt modelId="i3" type="node">
-      <dgm:t>
+    <dgm:pt modelId="{CBC6839A-2611-3DD9-E4A3-0715B28F1F4B}">
+      <dgm:prSet phldrT="[Text]"/>
+      <dgm:spPr/>
+      <dgm:t>
+        <a:bodyPr/>
+        <a:lstStyle/>
         <a:p>
           <a:r>
             <a:rPr lang="en-US"/>
@@ -372,8 +561,12 @@
         </a:p>
       </dgm:t>
     </dgm:pt>
-    <dgm:pt modelId="i4" type="node">
-      <dgm:t>
+    <dgm:pt modelId="{5904D56E-D738-D010-7514-2228A0A53AED}">
+      <dgm:prSet phldrT="[Text]"/>
+      <dgm:spPr/>
+      <dgm:t>
+        <a:bodyPr/>
+        <a:lstStyle/>
         <a:p>
           <a:r>
             <a:rPr lang="en-US"/>
@@ -384,14 +577,32 @@
     </dgm:pt>
   </dgm:ptLst>
   <dgm:cxnLst/>
+  <dgm:bg/>
+  <dgm:whole/>
+  <dgm:extLst/>
 </dgm:dataModel>
 </file>
 
 <file path=ppt/diagrams/data6.xml><?xml version="1.0" encoding="utf-8"?>
 <dgm:dataModel xmlns:dgm="http://schemas.openxmlformats.org/drawingml/2006/diagram" xmlns:a="http://schemas.openxmlformats.org/drawingml/2006/main">
   <dgm:ptLst>
-    <dgm:pt modelId="g1" type="node">
-      <dgm:t>
+    <dgm:pt modelId="{C6A8D919-34C9-3860-0464-A720F047D71C}" type="doc">
+      <dgm:prSet loTypeId="urn:microsoft.com/office/officeart/2005/8/layout/groupedList" loCatId="list" qsTypeId="urn:microsoft.com/office/officeart/2005/8/quickstyle/simple1" qsCatId="simple" csTypeId="urn:microsoft.com/office/officeart/2005/8/colors/accent1_2" csCatId="accent1" phldr="1"/>
+      <dgm:spPr/>
+      <dgm:t>
+        <a:bodyPr/>
+        <a:lstStyle/>
+        <a:p>
+          <a:endParaRPr lang="en-US"/>
+        </a:p>
+      </dgm:t>
+    </dgm:pt>
+    <dgm:pt modelId="{F6301471-4E16-8093-3D93-428BC1FAB80F}">
+      <dgm:prSet phldrT="[Text]"/>
+      <dgm:spPr/>
+      <dgm:t>
+        <a:bodyPr/>
+        <a:lstStyle/>
         <a:p>
           <a:r>
             <a:rPr lang="en-US"/>
@@ -400,8 +611,12 @@
         </a:p>
       </dgm:t>
     </dgm:pt>
-    <dgm:pt modelId="g1a" type="node">
-      <dgm:t>
+    <dgm:pt modelId="{60E457C9-4696-01FE-C9E3-30B846896419}">
+      <dgm:prSet phldrT="[Text]"/>
+      <dgm:spPr/>
+      <dgm:t>
+        <a:bodyPr/>
+        <a:lstStyle/>
         <a:p>
           <a:r>
             <a:rPr lang="en-US"/>
@@ -410,8 +625,12 @@
         </a:p>
       </dgm:t>
     </dgm:pt>
-    <dgm:pt modelId="g1b" type="node">
-      <dgm:t>
+    <dgm:pt modelId="{C8D58FEA-F8FC-0042-6AC5-67FBBB0AF581}">
+      <dgm:prSet phldrT="[Text]"/>
+      <dgm:spPr/>
+      <dgm:t>
+        <a:bodyPr/>
+        <a:lstStyle/>
         <a:p>
           <a:r>
             <a:rPr lang="en-US"/>
@@ -420,8 +639,12 @@
         </a:p>
       </dgm:t>
     </dgm:pt>
-    <dgm:pt modelId="g2" type="node">
-      <dgm:t>
+    <dgm:pt modelId="{664B2F4D-FC8C-E648-059D-36E91326BF87}">
+      <dgm:prSet phldrT="[Text]"/>
+      <dgm:spPr/>
+      <dgm:t>
+        <a:bodyPr/>
+        <a:lstStyle/>
         <a:p>
           <a:r>
             <a:rPr lang="en-US"/>
@@ -430,8 +653,12 @@
         </a:p>
       </dgm:t>
     </dgm:pt>
-    <dgm:pt modelId="g2a" type="node">
-      <dgm:t>
+    <dgm:pt modelId="{17050498-9538-1EF6-7023-81B7AB0D8BCF}">
+      <dgm:prSet phldrT="[Text]"/>
+      <dgm:spPr/>
+      <dgm:t>
+        <a:bodyPr/>
+        <a:lstStyle/>
         <a:p>
           <a:r>
             <a:rPr lang="en-US"/>
@@ -440,8 +667,12 @@
         </a:p>
       </dgm:t>
     </dgm:pt>
-    <dgm:pt modelId="g2b" type="node">
-      <dgm:t>
+    <dgm:pt modelId="{0DD2BE20-7741-752C-0186-AD5B516BF20F}">
+      <dgm:prSet phldrT="[Text]"/>
+      <dgm:spPr/>
+      <dgm:t>
+        <a:bodyPr/>
+        <a:lstStyle/>
         <a:p>
           <a:r>
             <a:rPr lang="en-US"/>
@@ -452,19 +683,37 @@
     </dgm:pt>
   </dgm:ptLst>
   <dgm:cxnLst>
-    <dgm:cxn type="parOf" srcId="g1" destId="g1a"/>
-    <dgm:cxn type="parOf" srcId="g1" destId="g1b"/>
-    <dgm:cxn type="parOf" srcId="g2" destId="g2a"/>
-    <dgm:cxn type="parOf" srcId="g2" destId="g2b"/>
+    <dgm:cxn modelId="{ECB1B67A-C573-805D-C1AF-F1C725EB1C72}" type="parOf" srcId="{F6301471-4E16-8093-3D93-428BC1FAB80F}" destId="{60E457C9-4696-01FE-C9E3-30B846896419}" srcOrd="0" destOrd="0"/>
+    <dgm:cxn modelId="{AB33F20D-2A2B-DBC0-D68D-B8A06EB6135E}" type="parOf" srcId="{F6301471-4E16-8093-3D93-428BC1FAB80F}" destId="{C8D58FEA-F8FC-0042-6AC5-67FBBB0AF581}" srcOrd="1" destOrd="1"/>
+    <dgm:cxn modelId="{9E685796-6A74-921F-75DE-35AA1DD20E5A}" type="parOf" srcId="{664B2F4D-FC8C-E648-059D-36E91326BF87}" destId="{17050498-9538-1EF6-7023-81B7AB0D8BCF}" srcOrd="2" destOrd="2"/>
+    <dgm:cxn modelId="{09C56081-E4BA-A092-5854-39A666C5B382}" type="parOf" srcId="{664B2F4D-FC8C-E648-059D-36E91326BF87}" destId="{0DD2BE20-7741-752C-0186-AD5B516BF20F}" srcOrd="3" destOrd="3"/>
   </dgm:cxnLst>
+  <dgm:bg/>
+  <dgm:whole/>
+  <dgm:extLst/>
 </dgm:dataModel>
 </file>
 
 <file path=ppt/diagrams/data7.xml><?xml version="1.0" encoding="utf-8"?>
 <dgm:dataModel xmlns:dgm="http://schemas.openxmlformats.org/drawingml/2006/diagram" xmlns:a="http://schemas.openxmlformats.org/drawingml/2006/main">
   <dgm:ptLst>
-    <dgm:pt modelId="rel1" type="node">
-      <dgm:t>
+    <dgm:pt modelId="{0ACF42BB-8804-FB95-F560-438B5074A20A}" type="doc">
+      <dgm:prSet loTypeId="urn:microsoft.com/office/officeart/2005/8/layout/relationship1" loCatId="list" qsTypeId="urn:microsoft.com/office/officeart/2005/8/quickstyle/simple1" qsCatId="simple" csTypeId="urn:microsoft.com/office/officeart/2005/8/colors/accent1_2" csCatId="accent1" phldr="1"/>
+      <dgm:spPr/>
+      <dgm:t>
+        <a:bodyPr/>
+        <a:lstStyle/>
+        <a:p>
+          <a:endParaRPr lang="en-US"/>
+        </a:p>
+      </dgm:t>
+    </dgm:pt>
+    <dgm:pt modelId="{09BAE74E-C8E1-74F7-0B9C-A0405CFDB357}">
+      <dgm:prSet phldrT="[Text]"/>
+      <dgm:spPr/>
+      <dgm:t>
+        <a:bodyPr/>
+        <a:lstStyle/>
         <a:p>
           <a:r>
             <a:rPr lang="en-US"/>
@@ -473,8 +722,12 @@
         </a:p>
       </dgm:t>
     </dgm:pt>
-    <dgm:pt modelId="rel2" type="node">
-      <dgm:t>
+    <dgm:pt modelId="{7ABBECCB-DD61-6345-4805-A6B1188BD702}">
+      <dgm:prSet phldrT="[Text]"/>
+      <dgm:spPr/>
+      <dgm:t>
+        <a:bodyPr/>
+        <a:lstStyle/>
         <a:p>
           <a:r>
             <a:rPr lang="en-US"/>
@@ -483,8 +736,12 @@
         </a:p>
       </dgm:t>
     </dgm:pt>
-    <dgm:pt modelId="rel3" type="node">
-      <dgm:t>
+    <dgm:pt modelId="{6E910E27-7EA6-1066-E598-319E741CC091}">
+      <dgm:prSet phldrT="[Text]"/>
+      <dgm:spPr/>
+      <dgm:t>
+        <a:bodyPr/>
+        <a:lstStyle/>
         <a:p>
           <a:r>
             <a:rPr lang="en-US"/>
@@ -495,14 +752,32 @@
     </dgm:pt>
   </dgm:ptLst>
   <dgm:cxnLst/>
+  <dgm:bg/>
+  <dgm:whole/>
+  <dgm:extLst/>
 </dgm:dataModel>
 </file>
 
 <file path=ppt/diagrams/data8.xml><?xml version="1.0" encoding="utf-8"?>
 <dgm:dataModel xmlns:dgm="http://schemas.openxmlformats.org/drawingml/2006/diagram" xmlns:a="http://schemas.openxmlformats.org/drawingml/2006/main">
   <dgm:ptLst>
-    <dgm:pt modelId="grid1" type="node">
-      <dgm:t>
+    <dgm:pt modelId="{A757DBDF-FC5A-2ABC-13AD-DBBF32918F08}" type="doc">
+      <dgm:prSet loTypeId="urn:microsoft.com/office/officeart/2005/8/layout/gridMatrix" loCatId="list" qsTypeId="urn:microsoft.com/office/officeart/2005/8/quickstyle/simple1" qsCatId="simple" csTypeId="urn:microsoft.com/office/officeart/2005/8/colors/accent1_2" csCatId="accent1" phldr="1"/>
+      <dgm:spPr/>
+      <dgm:t>
+        <a:bodyPr/>
+        <a:lstStyle/>
+        <a:p>
+          <a:endParaRPr lang="en-US"/>
+        </a:p>
+      </dgm:t>
+    </dgm:pt>
+    <dgm:pt modelId="{B22A8975-F2D0-9C62-6327-E8EEEA00BC40}">
+      <dgm:prSet phldrT="[Text]"/>
+      <dgm:spPr/>
+      <dgm:t>
+        <a:bodyPr/>
+        <a:lstStyle/>
         <a:p>
           <a:r>
             <a:rPr lang="en-US"/>
@@ -511,8 +786,12 @@
         </a:p>
       </dgm:t>
     </dgm:pt>
-    <dgm:pt modelId="grid2" type="node">
-      <dgm:t>
+    <dgm:pt modelId="{07945F23-6F9E-AAA3-69FD-9C862ED080DF}">
+      <dgm:prSet phldrT="[Text]"/>
+      <dgm:spPr/>
+      <dgm:t>
+        <a:bodyPr/>
+        <a:lstStyle/>
         <a:p>
           <a:r>
             <a:rPr lang="en-US"/>
@@ -521,8 +800,12 @@
         </a:p>
       </dgm:t>
     </dgm:pt>
-    <dgm:pt modelId="grid3" type="node">
-      <dgm:t>
+    <dgm:pt modelId="{887B391D-2D9F-9FB9-D36E-A66BE769D6FA}">
+      <dgm:prSet phldrT="[Text]"/>
+      <dgm:spPr/>
+      <dgm:t>
+        <a:bodyPr/>
+        <a:lstStyle/>
         <a:p>
           <a:r>
             <a:rPr lang="en-US"/>
@@ -531,8 +814,12 @@
         </a:p>
       </dgm:t>
     </dgm:pt>
-    <dgm:pt modelId="grid4" type="node">
-      <dgm:t>
+    <dgm:pt modelId="{1FCC0858-8D7C-27CF-2A78-131A9B1A5241}">
+      <dgm:prSet phldrT="[Text]"/>
+      <dgm:spPr/>
+      <dgm:t>
+        <a:bodyPr/>
+        <a:lstStyle/>
         <a:p>
           <a:r>
             <a:rPr lang="en-US"/>
@@ -543,14 +830,32 @@
     </dgm:pt>
   </dgm:ptLst>
   <dgm:cxnLst/>
+  <dgm:bg/>
+  <dgm:whole/>
+  <dgm:extLst/>
 </dgm:dataModel>
 </file>
 
 <file path=ppt/diagrams/data9.xml><?xml version="1.0" encoding="utf-8"?>
 <dgm:dataModel xmlns:dgm="http://schemas.openxmlformats.org/drawingml/2006/diagram" xmlns:a="http://schemas.openxmlformats.org/drawingml/2006/main">
   <dgm:ptLst>
-    <dgm:pt modelId="inc1" type="node">
-      <dgm:t>
+    <dgm:pt modelId="{05261832-59A8-E8A3-4B8E-0EF8848A3BC7}" type="doc">
+      <dgm:prSet loTypeId="urn:microsoft.com/office/officeart/2005/8/layout/increasingCircleProcess" loCatId="list" qsTypeId="urn:microsoft.com/office/officeart/2005/8/quickstyle/simple1" qsCatId="simple" csTypeId="urn:microsoft.com/office/officeart/2005/8/colors/accent1_2" csCatId="accent1" phldr="1"/>
+      <dgm:spPr/>
+      <dgm:t>
+        <a:bodyPr/>
+        <a:lstStyle/>
+        <a:p>
+          <a:endParaRPr lang="en-US"/>
+        </a:p>
+      </dgm:t>
+    </dgm:pt>
+    <dgm:pt modelId="{B2F549FF-ADF0-09ED-5860-D2C231ACE104}">
+      <dgm:prSet phldrT="[Text]"/>
+      <dgm:spPr/>
+      <dgm:t>
+        <a:bodyPr/>
+        <a:lstStyle/>
         <a:p>
           <a:r>
             <a:rPr lang="en-US"/>
@@ -559,8 +864,12 @@
         </a:p>
       </dgm:t>
     </dgm:pt>
-    <dgm:pt modelId="inc2" type="node">
-      <dgm:t>
+    <dgm:pt modelId="{B88B3F1C-47AA-D88C-FF39-7E8EB1719589}">
+      <dgm:prSet phldrT="[Text]"/>
+      <dgm:spPr/>
+      <dgm:t>
+        <a:bodyPr/>
+        <a:lstStyle/>
         <a:p>
           <a:r>
             <a:rPr lang="en-US"/>
@@ -569,8 +878,12 @@
         </a:p>
       </dgm:t>
     </dgm:pt>
-    <dgm:pt modelId="inc3" type="node">
-      <dgm:t>
+    <dgm:pt modelId="{FDC404EE-6AB0-19F7-1664-D683B52F01A8}">
+      <dgm:prSet phldrT="[Text]"/>
+      <dgm:spPr/>
+      <dgm:t>
+        <a:bodyPr/>
+        <a:lstStyle/>
         <a:p>
           <a:r>
             <a:rPr lang="en-US"/>
@@ -579,8 +892,12 @@
         </a:p>
       </dgm:t>
     </dgm:pt>
-    <dgm:pt modelId="inc4" type="node">
-      <dgm:t>
+    <dgm:pt modelId="{3FF15551-09A0-E6C9-313A-81B76FEF91C3}">
+      <dgm:prSet phldrT="[Text]"/>
+      <dgm:spPr/>
+      <dgm:t>
+        <a:bodyPr/>
+        <a:lstStyle/>
         <a:p>
           <a:r>
             <a:rPr lang="en-US"/>
@@ -591,21 +908,28 @@
     </dgm:pt>
   </dgm:ptLst>
   <dgm:cxnLst>
-    <dgm:cxn type="parOf" srcId="inc1" destId="inc2"/>
-    <dgm:cxn type="parOf" srcId="inc2" destId="inc3"/>
-    <dgm:cxn type="parOf" srcId="inc3" destId="inc4"/>
+    <dgm:cxn modelId="{0C25F715-57EE-4E5C-EE63-586B63B476E8}" type="parOf" srcId="{B2F549FF-ADF0-09ED-5860-D2C231ACE104}" destId="{B88B3F1C-47AA-D88C-FF39-7E8EB1719589}" srcOrd="0" destOrd="0"/>
+    <dgm:cxn modelId="{B4D10FAC-6678-73A7-C0F5-133805220347}" type="parOf" srcId="{B88B3F1C-47AA-D88C-FF39-7E8EB1719589}" destId="{FDC404EE-6AB0-19F7-1664-D683B52F01A8}" srcOrd="1" destOrd="1"/>
+    <dgm:cxn modelId="{598977CC-CC99-3CF1-8F96-49C55E3259AE}" type="parOf" srcId="{FDC404EE-6AB0-19F7-1664-D683B52F01A8}" destId="{3FF15551-09A0-E6C9-313A-81B76FEF91C3}" srcOrd="2" destOrd="2"/>
   </dgm:cxnLst>
+  <dgm:bg/>
+  <dgm:whole/>
+  <dgm:extLst/>
 </dgm:dataModel>
 </file>
 
 <file path=ppt/diagrams/drawing1.xml><?xml version="1.0" encoding="utf-8"?>
 <dsp:drawing xmlns:dsp="http://schemas.microsoft.com/office/drawing/2008/diagram" xmlns:a="http://schemas.openxmlformats.org/drawingml/2006/main">
   <dsp:spTree>
-    <dsp:sp>
+    <dsp:nvGrpSpPr>
+      <dsp:cNvPr id="0" name=""/>
+      <dsp:cNvGrpSpPr/>
+    </dsp:nvGrpSpPr>
+    <dsp:grpSpPr/>
+    <dsp:sp modelId="{43AA6742-3387-93FB-0B7A-ADA76DE92051}">
       <dsp:nvSpPr>
         <dsp:cNvPr id="10" name="Process1 node 1"/>
         <dsp:cNvSpPr/>
-        <dsp:nvPr/>
       </dsp:nvSpPr>
       <dsp:spPr>
         <a:xfrm>
@@ -631,11 +955,10 @@
         </a:p>
       </dsp:txBody>
     </dsp:sp>
-    <dsp:sp>
+    <dsp:sp modelId="{87C154F6-0FF3-DD66-A654-167198A539A1}">
       <dsp:nvSpPr>
         <dsp:cNvPr id="20" name="Process1 connector 1"/>
         <dsp:cNvSpPr/>
-        <dsp:nvPr/>
       </dsp:nvSpPr>
       <dsp:spPr>
         <a:xfrm>
@@ -650,11 +973,10 @@
         </a:ln>
       </dsp:spPr>
     </dsp:sp>
-    <dsp:sp>
+    <dsp:sp modelId="{D0475CBB-026C-9896-764C-9FB8F9D1287C}">
       <dsp:nvSpPr>
         <dsp:cNvPr id="11" name="Process1 node 2"/>
         <dsp:cNvSpPr/>
-        <dsp:nvPr/>
       </dsp:nvSpPr>
       <dsp:spPr>
         <a:xfrm>
@@ -680,11 +1002,10 @@
         </a:p>
       </dsp:txBody>
     </dsp:sp>
-    <dsp:sp>
+    <dsp:sp modelId="{9B241953-0272-9C71-5C33-4246A8A0FF05}">
       <dsp:nvSpPr>
         <dsp:cNvPr id="21" name="Process1 connector 2"/>
         <dsp:cNvSpPr/>
-        <dsp:nvPr/>
       </dsp:nvSpPr>
       <dsp:spPr>
         <a:xfrm>
@@ -699,11 +1020,10 @@
         </a:ln>
       </dsp:spPr>
     </dsp:sp>
-    <dsp:sp>
+    <dsp:sp modelId="{7AF78161-E724-A585-1FC3-81BCEF8A6E1F}">
       <dsp:nvSpPr>
         <dsp:cNvPr id="12" name="Process1 node 3"/>
         <dsp:cNvSpPr/>
-        <dsp:nvPr/>
       </dsp:nvSpPr>
       <dsp:spPr>
         <a:xfrm>
@@ -729,11 +1049,10 @@
         </a:p>
       </dsp:txBody>
     </dsp:sp>
-    <dsp:sp>
+    <dsp:sp modelId="{0C1F8397-A6C6-19F4-B167-ED5FE9E9CEA6}">
       <dsp:nvSpPr>
         <dsp:cNvPr id="22" name="Process1 connector 3"/>
         <dsp:cNvSpPr/>
-        <dsp:nvPr/>
       </dsp:nvSpPr>
       <dsp:spPr>
         <a:xfrm>
@@ -748,11 +1067,10 @@
         </a:ln>
       </dsp:spPr>
     </dsp:sp>
-    <dsp:sp>
+    <dsp:sp modelId="{324FF822-FA10-5C3B-2D9F-0853337B7298}">
       <dsp:nvSpPr>
         <dsp:cNvPr id="13" name="Process1 node 4"/>
         <dsp:cNvSpPr/>
-        <dsp:nvPr/>
       </dsp:nvSpPr>
       <dsp:spPr>
         <a:xfrm>
@@ -778,11 +1096,10 @@
         </a:p>
       </dsp:txBody>
     </dsp:sp>
-    <dsp:sp>
+    <dsp:sp modelId="{780EAB5D-3581-13BF-28E7-4BCA70FC763F}">
       <dsp:nvSpPr>
         <dsp:cNvPr id="23" name="Process1 connector 4"/>
         <dsp:cNvSpPr/>
-        <dsp:nvPr/>
       </dsp:nvSpPr>
       <dsp:spPr>
         <a:xfrm>
@@ -797,11 +1114,10 @@
         </a:ln>
       </dsp:spPr>
     </dsp:sp>
-    <dsp:sp>
+    <dsp:sp modelId="{1C3741EF-E28A-99C1-3CF7-CD4C5DA2F612}">
       <dsp:nvSpPr>
         <dsp:cNvPr id="14" name="Process1 node 5"/>
         <dsp:cNvSpPr/>
-        <dsp:nvPr/>
       </dsp:nvSpPr>
       <dsp:spPr>
         <a:xfrm>
@@ -834,11 +1150,15 @@
 <file path=ppt/diagrams/drawing10.xml><?xml version="1.0" encoding="utf-8"?>
 <dsp:drawing xmlns:dsp="http://schemas.microsoft.com/office/drawing/2008/diagram" xmlns:a="http://schemas.openxmlformats.org/drawingml/2006/main">
   <dsp:spTree>
-    <dsp:sp>
+    <dsp:nvGrpSpPr>
+      <dsp:cNvPr id="0" name=""/>
+      <dsp:cNvGrpSpPr/>
+    </dsp:nvGrpSpPr>
+    <dsp:grpSpPr/>
+    <dsp:sp modelId="{45DE7EE2-218F-694A-7282-5557EEA10AD6}">
       <dsp:nvSpPr>
         <dsp:cNvPr id="110" name="VerticalArrowList node 1"/>
         <dsp:cNvSpPr/>
-        <dsp:nvPr/>
       </dsp:nvSpPr>
       <dsp:spPr>
         <a:xfrm>
@@ -864,11 +1184,10 @@
         </a:p>
       </dsp:txBody>
     </dsp:sp>
-    <dsp:sp>
+    <dsp:sp modelId="{235496A2-CFDD-E5B8-9525-1525069B4F0A}">
       <dsp:nvSpPr>
         <dsp:cNvPr id="111" name="VerticalArrowList node 2"/>
         <dsp:cNvSpPr/>
-        <dsp:nvPr/>
       </dsp:nvSpPr>
       <dsp:spPr>
         <a:xfrm>
@@ -894,11 +1213,10 @@
         </a:p>
       </dsp:txBody>
     </dsp:sp>
-    <dsp:sp>
+    <dsp:sp modelId="{1A98974F-1B5D-70D4-7C2C-EDF2D133B113}">
       <dsp:nvSpPr>
         <dsp:cNvPr id="112" name="VerticalArrowList node 3"/>
         <dsp:cNvSpPr/>
-        <dsp:nvPr/>
       </dsp:nvSpPr>
       <dsp:spPr>
         <a:xfrm>
@@ -924,11 +1242,10 @@
         </a:p>
       </dsp:txBody>
     </dsp:sp>
-    <dsp:sp>
+    <dsp:sp modelId="{D8B39CDA-2160-7BFA-D14C-12E924E976A5}">
       <dsp:nvSpPr>
         <dsp:cNvPr id="113" name="VerticalArrowList node 4"/>
         <dsp:cNvSpPr/>
-        <dsp:nvPr/>
       </dsp:nvSpPr>
       <dsp:spPr>
         <a:xfrm>
@@ -959,19 +1276,29 @@
 </file>
 
 <file path=ppt/diagrams/drawing2.xml><?xml version="1.0" encoding="utf-8"?>
-<dsp:drawing xmlns:dsp="http://schemas.microsoft.com/office/drawing/2008/diagram">
-  <dsp:spTree/>
+<dsp:drawing xmlns:dsp="http://schemas.microsoft.com/office/drawing/2008/diagram" xmlns:a="http://schemas.openxmlformats.org/drawingml/2006/main">
+  <dsp:spTree>
+    <dsp:nvGrpSpPr>
+      <dsp:cNvPr id="0" name=""/>
+      <dsp:cNvGrpSpPr/>
+    </dsp:nvGrpSpPr>
+    <dsp:grpSpPr/>
+  </dsp:spTree>
 </dsp:drawing>
 </file>
 
 <file path=ppt/diagrams/drawing3.xml><?xml version="1.0" encoding="utf-8"?>
 <dsp:drawing xmlns:dsp="http://schemas.microsoft.com/office/drawing/2008/diagram" xmlns:a="http://schemas.openxmlformats.org/drawingml/2006/main">
   <dsp:spTree>
-    <dsp:sp>
+    <dsp:nvGrpSpPr>
+      <dsp:cNvPr id="0" name=""/>
+      <dsp:cNvGrpSpPr/>
+    </dsp:nvGrpSpPr>
+    <dsp:grpSpPr/>
+    <dsp:sp modelId="{3A21AED2-2C01-4A38-A3C7-E0A8D3593180}">
       <dsp:nvSpPr>
         <dsp:cNvPr id="10" name="Hierarchy3 node 1"/>
         <dsp:cNvSpPr/>
-        <dsp:nvPr/>
       </dsp:nvSpPr>
       <dsp:spPr>
         <a:xfrm>
@@ -997,11 +1324,10 @@
         </a:p>
       </dsp:txBody>
     </dsp:sp>
-    <dsp:sp>
+    <dsp:sp modelId="{168421E9-E26D-793E-AD21-8499633F9682}">
       <dsp:nvSpPr>
         <dsp:cNvPr id="11" name="Hierarchy3 node 2"/>
         <dsp:cNvSpPr/>
-        <dsp:nvPr/>
       </dsp:nvSpPr>
       <dsp:spPr>
         <a:xfrm>
@@ -1027,11 +1353,10 @@
         </a:p>
       </dsp:txBody>
     </dsp:sp>
-    <dsp:sp>
+    <dsp:sp modelId="{79FFF9FF-B500-E97C-E27C-2E9AE03792B0}">
       <dsp:nvSpPr>
         <dsp:cNvPr id="12" name="Hierarchy3 node 3"/>
         <dsp:cNvSpPr/>
-        <dsp:nvPr/>
       </dsp:nvSpPr>
       <dsp:spPr>
         <a:xfrm>
@@ -1057,11 +1382,10 @@
         </a:p>
       </dsp:txBody>
     </dsp:sp>
-    <dsp:sp>
+    <dsp:sp modelId="{1B2EB3CC-18AB-B94C-8F83-B7C6D1C61EA7}">
       <dsp:nvSpPr>
         <dsp:cNvPr id="13" name="Hierarchy3 node 4"/>
         <dsp:cNvSpPr/>
-        <dsp:nvPr/>
       </dsp:nvSpPr>
       <dsp:spPr>
         <a:xfrm>
@@ -1087,11 +1411,10 @@
         </a:p>
       </dsp:txBody>
     </dsp:sp>
-    <dsp:sp>
+    <dsp:sp modelId="{7F3808C9-D537-42AA-B3C7-D0FEEB4A99E8}">
       <dsp:nvSpPr>
         <dsp:cNvPr id="30" name="Hierarchy3 template 1"/>
         <dsp:cNvSpPr/>
-        <dsp:nvPr/>
       </dsp:nvSpPr>
       <dsp:spPr>
         <a:xfrm>
@@ -1107,11 +1430,10 @@
         <a:ln/>
       </dsp:spPr>
     </dsp:sp>
-    <dsp:sp>
+    <dsp:sp modelId="{F2431150-BE84-9543-041F-F269287D298B}">
       <dsp:nvSpPr>
         <dsp:cNvPr id="31" name="Hierarchy3 template 2"/>
         <dsp:cNvSpPr/>
-        <dsp:nvPr/>
       </dsp:nvSpPr>
       <dsp:spPr>
         <a:xfrm>
@@ -1127,11 +1449,10 @@
         <a:ln/>
       </dsp:spPr>
     </dsp:sp>
-    <dsp:sp>
+    <dsp:sp modelId="{8885ACDC-FE56-EDED-92EA-AA1D286E93F0}">
       <dsp:nvSpPr>
         <dsp:cNvPr id="20" name="Hierarchy3 connector 1"/>
         <dsp:cNvSpPr/>
-        <dsp:nvPr/>
       </dsp:nvSpPr>
       <dsp:spPr>
         <a:xfrm>
@@ -1146,11 +1467,10 @@
         </a:ln>
       </dsp:spPr>
     </dsp:sp>
-    <dsp:sp>
+    <dsp:sp modelId="{23C4F5F0-B855-C0E1-6ACB-FA791FB54439}">
       <dsp:nvSpPr>
         <dsp:cNvPr id="21" name="Hierarchy3 connector 2"/>
         <dsp:cNvSpPr/>
-        <dsp:nvPr/>
       </dsp:nvSpPr>
       <dsp:spPr>
         <a:xfrm>
@@ -1165,11 +1485,10 @@
         </a:ln>
       </dsp:spPr>
     </dsp:sp>
-    <dsp:sp>
+    <dsp:sp modelId="{B204C941-C656-025C-7FD2-7AF0D24FFBE1}">
       <dsp:nvSpPr>
         <dsp:cNvPr id="22" name="Hierarchy3 connector 3"/>
         <dsp:cNvSpPr/>
-        <dsp:nvPr/>
       </dsp:nvSpPr>
       <dsp:spPr>
         <a:xfrm>
@@ -1184,11 +1503,10 @@
         </a:ln>
       </dsp:spPr>
     </dsp:sp>
-    <dsp:sp>
+    <dsp:sp modelId="{DF5F55EA-5C23-8E83-90B0-18AC39CB7630}">
       <dsp:nvSpPr>
         <dsp:cNvPr id="23" name="Hierarchy3 connector 4"/>
         <dsp:cNvSpPr/>
-        <dsp:nvPr/>
       </dsp:nvSpPr>
       <dsp:spPr>
         <a:xfrm>
@@ -1208,25 +1526,41 @@
 </file>
 
 <file path=ppt/diagrams/drawing4.xml><?xml version="1.0" encoding="utf-8"?>
-<dsp:drawing xmlns:dsp="http://schemas.microsoft.com/office/drawing/2008/diagram">
-  <dsp:spTree/>
+<dsp:drawing xmlns:dsp="http://schemas.microsoft.com/office/drawing/2008/diagram" xmlns:a="http://schemas.openxmlformats.org/drawingml/2006/main">
+  <dsp:spTree>
+    <dsp:nvGrpSpPr>
+      <dsp:cNvPr id="0" name=""/>
+      <dsp:cNvGrpSpPr/>
+    </dsp:nvGrpSpPr>
+    <dsp:grpSpPr/>
+  </dsp:spTree>
 </dsp:drawing>
 </file>
 
 <file path=ppt/diagrams/drawing5.xml><?xml version="1.0" encoding="utf-8"?>
-<dsp:drawing xmlns:dsp="http://schemas.microsoft.com/office/drawing/2008/diagram">
-  <dsp:spTree/>
+<dsp:drawing xmlns:dsp="http://schemas.microsoft.com/office/drawing/2008/diagram" xmlns:a="http://schemas.openxmlformats.org/drawingml/2006/main">
+  <dsp:spTree>
+    <dsp:nvGrpSpPr>
+      <dsp:cNvPr id="0" name=""/>
+      <dsp:cNvGrpSpPr/>
+    </dsp:nvGrpSpPr>
+    <dsp:grpSpPr/>
+  </dsp:spTree>
 </dsp:drawing>
 </file>
 
 <file path=ppt/diagrams/drawing6.xml><?xml version="1.0" encoding="utf-8"?>
 <dsp:drawing xmlns:dsp="http://schemas.microsoft.com/office/drawing/2008/diagram" xmlns:a="http://schemas.openxmlformats.org/drawingml/2006/main">
   <dsp:spTree>
-    <dsp:sp>
+    <dsp:nvGrpSpPr>
+      <dsp:cNvPr id="0" name=""/>
+      <dsp:cNvGrpSpPr/>
+    </dsp:nvGrpSpPr>
+    <dsp:grpSpPr/>
+    <dsp:sp modelId="{540BDD96-DE52-9490-99D2-7BC15C7440C4}">
       <dsp:nvSpPr>
         <dsp:cNvPr id="40" name="GroupedList band 1"/>
         <dsp:cNvSpPr/>
-        <dsp:nvPr/>
       </dsp:nvSpPr>
       <dsp:spPr>
         <a:xfrm>
@@ -1242,11 +1576,10 @@
         <a:ln/>
       </dsp:spPr>
     </dsp:sp>
-    <dsp:sp>
+    <dsp:sp modelId="{69CF3CD7-80E1-63C5-35AB-3B224974DB79}">
       <dsp:nvSpPr>
         <dsp:cNvPr id="50" name="GroupedList header 1"/>
         <dsp:cNvSpPr/>
-        <dsp:nvPr/>
       </dsp:nvSpPr>
       <dsp:spPr>
         <a:xfrm>
@@ -1272,11 +1605,10 @@
         </a:p>
       </dsp:txBody>
     </dsp:sp>
-    <dsp:sp>
+    <dsp:sp modelId="{283CE4C1-2898-C1BF-2D6A-F5E7030D10C6}">
       <dsp:nvSpPr>
         <dsp:cNvPr id="60" name="GroupedList child 1.1"/>
         <dsp:cNvSpPr/>
-        <dsp:nvPr/>
       </dsp:nvSpPr>
       <dsp:spPr>
         <a:xfrm>
@@ -1302,11 +1634,10 @@
         </a:p>
       </dsp:txBody>
     </dsp:sp>
-    <dsp:sp>
+    <dsp:sp modelId="{6797CB76-D7A4-5CB3-455A-706F366230AE}">
       <dsp:nvSpPr>
         <dsp:cNvPr id="61" name="GroupedList child 1.2"/>
         <dsp:cNvSpPr/>
-        <dsp:nvPr/>
       </dsp:nvSpPr>
       <dsp:spPr>
         <a:xfrm>
@@ -1332,11 +1663,10 @@
         </a:p>
       </dsp:txBody>
     </dsp:sp>
-    <dsp:sp>
+    <dsp:sp modelId="{00D1D49C-5C8F-0A0F-297D-85AC92BC5561}">
       <dsp:nvSpPr>
         <dsp:cNvPr id="41" name="GroupedList band 2"/>
         <dsp:cNvSpPr/>
-        <dsp:nvPr/>
       </dsp:nvSpPr>
       <dsp:spPr>
         <a:xfrm>
@@ -1352,11 +1682,10 @@
         <a:ln/>
       </dsp:spPr>
     </dsp:sp>
-    <dsp:sp>
+    <dsp:sp modelId="{ED0332CC-3527-D772-843E-5BF6194E641B}">
       <dsp:nvSpPr>
         <dsp:cNvPr id="51" name="GroupedList header 2"/>
         <dsp:cNvSpPr/>
-        <dsp:nvPr/>
       </dsp:nvSpPr>
       <dsp:spPr>
         <a:xfrm>
@@ -1382,11 +1711,10 @@
         </a:p>
       </dsp:txBody>
     </dsp:sp>
-    <dsp:sp>
+    <dsp:sp modelId="{0C872806-F4D8-14C7-8859-FE3040AB3E48}">
       <dsp:nvSpPr>
         <dsp:cNvPr id="62" name="GroupedList child 2.1"/>
         <dsp:cNvSpPr/>
-        <dsp:nvPr/>
       </dsp:nvSpPr>
       <dsp:spPr>
         <a:xfrm>
@@ -1412,11 +1740,10 @@
         </a:p>
       </dsp:txBody>
     </dsp:sp>
-    <dsp:sp>
+    <dsp:sp modelId="{571A12E0-010E-328B-E70D-06C91EB5D31B}">
       <dsp:nvSpPr>
         <dsp:cNvPr id="63" name="GroupedList child 2.2"/>
         <dsp:cNvSpPr/>
-        <dsp:nvPr/>
       </dsp:nvSpPr>
       <dsp:spPr>
         <a:xfrm>
@@ -1449,11 +1776,15 @@
 <file path=ppt/diagrams/drawing7.xml><?xml version="1.0" encoding="utf-8"?>
 <dsp:drawing xmlns:dsp="http://schemas.microsoft.com/office/drawing/2008/diagram" xmlns:a="http://schemas.openxmlformats.org/drawingml/2006/main">
   <dsp:spTree>
-    <dsp:sp>
+    <dsp:nvGrpSpPr>
+      <dsp:cNvPr id="0" name=""/>
+      <dsp:cNvGrpSpPr/>
+    </dsp:nvGrpSpPr>
+    <dsp:grpSpPr/>
+    <dsp:sp modelId="{0ED4EE40-BD2E-12E8-C355-357F7E2F35D2}">
       <dsp:nvSpPr>
         <dsp:cNvPr id="70" name="Relationship1 node 1"/>
         <dsp:cNvSpPr/>
-        <dsp:nvPr/>
       </dsp:nvSpPr>
       <dsp:spPr>
         <a:xfrm>
@@ -1479,11 +1810,10 @@
         </a:p>
       </dsp:txBody>
     </dsp:sp>
-    <dsp:sp>
+    <dsp:sp modelId="{F5543479-3A20-09BD-1537-E777DB106CA0}">
       <dsp:nvSpPr>
         <dsp:cNvPr id="71" name="Relationship1 node 2"/>
         <dsp:cNvSpPr/>
-        <dsp:nvPr/>
       </dsp:nvSpPr>
       <dsp:spPr>
         <a:xfrm>
@@ -1509,11 +1839,10 @@
         </a:p>
       </dsp:txBody>
     </dsp:sp>
-    <dsp:sp>
+    <dsp:sp modelId="{17084896-F2FB-CE01-6188-005FAB4B8FD7}">
       <dsp:nvSpPr>
         <dsp:cNvPr id="72" name="Relationship1 node 3"/>
         <dsp:cNvSpPr/>
-        <dsp:nvPr/>
       </dsp:nvSpPr>
       <dsp:spPr>
         <a:xfrm>
@@ -1546,11 +1875,15 @@
 <file path=ppt/diagrams/drawing8.xml><?xml version="1.0" encoding="utf-8"?>
 <dsp:drawing xmlns:dsp="http://schemas.microsoft.com/office/drawing/2008/diagram" xmlns:a="http://schemas.openxmlformats.org/drawingml/2006/main">
   <dsp:spTree>
-    <dsp:sp>
+    <dsp:nvGrpSpPr>
+      <dsp:cNvPr id="0" name=""/>
+      <dsp:cNvGrpSpPr/>
+    </dsp:nvGrpSpPr>
+    <dsp:grpSpPr/>
+    <dsp:sp modelId="{C0D2C1FC-C6E1-5756-B7A6-335233FA85BB}">
       <dsp:nvSpPr>
         <dsp:cNvPr id="80" name="GridMatrix cell 1"/>
         <dsp:cNvSpPr/>
-        <dsp:nvPr/>
       </dsp:nvSpPr>
       <dsp:spPr>
         <a:xfrm>
@@ -1576,11 +1909,10 @@
         </a:p>
       </dsp:txBody>
     </dsp:sp>
-    <dsp:sp>
+    <dsp:sp modelId="{950419B9-80C7-8AA7-6C45-EA8D2B247F80}">
       <dsp:nvSpPr>
         <dsp:cNvPr id="81" name="GridMatrix cell 2"/>
         <dsp:cNvSpPr/>
-        <dsp:nvPr/>
       </dsp:nvSpPr>
       <dsp:spPr>
         <a:xfrm>
@@ -1606,11 +1938,10 @@
         </a:p>
       </dsp:txBody>
     </dsp:sp>
-    <dsp:sp>
+    <dsp:sp modelId="{66CF0CA6-A186-2716-F508-7AD8E2CA1A68}">
       <dsp:nvSpPr>
         <dsp:cNvPr id="82" name="GridMatrix cell 3"/>
         <dsp:cNvSpPr/>
-        <dsp:nvPr/>
       </dsp:nvSpPr>
       <dsp:spPr>
         <a:xfrm>
@@ -1636,11 +1967,10 @@
         </a:p>
       </dsp:txBody>
     </dsp:sp>
-    <dsp:sp>
+    <dsp:sp modelId="{31767E63-0FBF-A7D0-6968-E9E3BDFEDE87}">
       <dsp:nvSpPr>
         <dsp:cNvPr id="83" name="GridMatrix cell 4"/>
         <dsp:cNvSpPr/>
-        <dsp:nvPr/>
       </dsp:nvSpPr>
       <dsp:spPr>
         <a:xfrm>
@@ -1673,11 +2003,15 @@
 <file path=ppt/diagrams/drawing9.xml><?xml version="1.0" encoding="utf-8"?>
 <dsp:drawing xmlns:dsp="http://schemas.microsoft.com/office/drawing/2008/diagram" xmlns:a="http://schemas.openxmlformats.org/drawingml/2006/main">
   <dsp:spTree>
-    <dsp:sp>
+    <dsp:nvGrpSpPr>
+      <dsp:cNvPr id="0" name=""/>
+      <dsp:cNvGrpSpPr/>
+    </dsp:nvGrpSpPr>
+    <dsp:grpSpPr/>
+    <dsp:sp modelId="{BBF00071-5B42-FF1B-E0BC-4807E791FFAE}">
       <dsp:nvSpPr>
         <dsp:cNvPr id="90" name="IncreasingCircleProcess node 1"/>
         <dsp:cNvSpPr/>
-        <dsp:nvPr/>
       </dsp:nvSpPr>
       <dsp:spPr>
         <a:xfrm>
@@ -1703,11 +2037,10 @@
         </a:p>
       </dsp:txBody>
     </dsp:sp>
-    <dsp:sp>
+    <dsp:sp modelId="{16E50938-172B-59A2-3EB1-C479D45D1E9C}">
       <dsp:nvSpPr>
         <dsp:cNvPr id="91" name="IncreasingCircleProcess node 2"/>
         <dsp:cNvSpPr/>
-        <dsp:nvPr/>
       </dsp:nvSpPr>
       <dsp:spPr>
         <a:xfrm>
@@ -1733,11 +2066,10 @@
         </a:p>
       </dsp:txBody>
     </dsp:sp>
-    <dsp:sp>
+    <dsp:sp modelId="{24DA1330-E009-C304-D5E2-CFD4DA9A15FD}">
       <dsp:nvSpPr>
         <dsp:cNvPr id="92" name="IncreasingCircleProcess node 3"/>
         <dsp:cNvSpPr/>
-        <dsp:nvPr/>
       </dsp:nvSpPr>
       <dsp:spPr>
         <a:xfrm>
@@ -1763,11 +2095,10 @@
         </a:p>
       </dsp:txBody>
     </dsp:sp>
-    <dsp:sp>
+    <dsp:sp modelId="{BF9548B6-C60A-F396-8D42-6729D63A3103}">
       <dsp:nvSpPr>
         <dsp:cNvPr id="93" name="IncreasingCircleProcess node 4"/>
         <dsp:cNvSpPr/>
-        <dsp:nvPr/>
       </dsp:nvSpPr>
       <dsp:spPr>
         <a:xfrm>
@@ -1793,11 +2124,10 @@
         </a:p>
       </dsp:txBody>
     </dsp:sp>
-    <dsp:sp>
+    <dsp:sp modelId="{73C431A6-CB66-1B2F-EAE0-3AD344A724E6}">
       <dsp:nvSpPr>
         <dsp:cNvPr id="100" name="IncreasingCircleProcess connector 1"/>
         <dsp:cNvSpPr/>
-        <dsp:nvPr/>
       </dsp:nvSpPr>
       <dsp:spPr>
         <a:xfrm>
@@ -1812,11 +2142,10 @@
         </a:ln>
       </dsp:spPr>
     </dsp:sp>
-    <dsp:sp>
+    <dsp:sp modelId="{4BA75566-7521-0DE6-FC70-42BA470C00A2}">
       <dsp:nvSpPr>
         <dsp:cNvPr id="101" name="IncreasingCircleProcess connector 2"/>
         <dsp:cNvSpPr/>
-        <dsp:nvPr/>
       </dsp:nvSpPr>
       <dsp:spPr>
         <a:xfrm>
@@ -1831,11 +2160,10 @@
         </a:ln>
       </dsp:spPr>
     </dsp:sp>
-    <dsp:sp>
+    <dsp:sp modelId="{CC9121BD-58C6-D96A-BB0C-84A749893A10}">
       <dsp:nvSpPr>
         <dsp:cNvPr id="102" name="IncreasingCircleProcess connector 3"/>
         <dsp:cNvSpPr/>
-        <dsp:nvPr/>
       </dsp:nvSpPr>
       <dsp:spPr>
         <a:xfrm>
@@ -1855,87 +2183,477 @@
 </file>
 
 <file path=ppt/diagrams/layout1.xml><?xml version="1.0" encoding="utf-8"?>
-<dgm:layoutDef xmlns:dgm="http://schemas.openxmlformats.org/drawingml/2006/diagram" uniqueId="urn:microsoft.com/office/officeart/2005/8/layout/process1"/>
+<dgm:layoutDef xmlns:dgm="http://schemas.openxmlformats.org/drawingml/2006/diagram" uniqueId="urn:microsoft.com/office/officeart/2005/8/layout/process1">
+  <dgm:title val="FreeP SmartArt"/>
+  <dgm:desc val="Deterministic FreeP SmartArt fixture"/>
+  <dgm:catLst/>
+  <dgm:sampData/>
+  <dgm:styleData/>
+  <dgm:clrData/>
+  <dgm:layoutNode name="root">
+    <dgm:varLst/>
+    <dgm:alg type="lin"/>
+    <dgm:shape type="rect">
+      <dgm:adjLst/>
+    </dgm:shape>
+    <dgm:presOf/>
+    <dgm:constrLst/>
+    <dgm:ruleLst/>
+  </dgm:layoutNode>
+</dgm:layoutDef>
 </file>
 
 <file path=ppt/diagrams/layout10.xml><?xml version="1.0" encoding="utf-8"?>
-<dgm:layoutDef xmlns:dgm="http://schemas.openxmlformats.org/drawingml/2006/diagram" uniqueId="urn:microsoft.com/office/officeart/2005/8/layout/verticalArrowList"/>
+<dgm:layoutDef xmlns:dgm="http://schemas.openxmlformats.org/drawingml/2006/diagram" uniqueId="urn:microsoft.com/office/officeart/2005/8/layout/verticalArrowList">
+  <dgm:title val="FreeP SmartArt"/>
+  <dgm:desc val="Deterministic FreeP SmartArt fixture"/>
+  <dgm:catLst/>
+  <dgm:sampData/>
+  <dgm:styleData/>
+  <dgm:clrData/>
+  <dgm:layoutNode name="root">
+    <dgm:varLst/>
+    <dgm:alg type="lin"/>
+    <dgm:shape type="rect">
+      <dgm:adjLst/>
+    </dgm:shape>
+    <dgm:presOf/>
+    <dgm:constrLst/>
+    <dgm:ruleLst/>
+  </dgm:layoutNode>
+</dgm:layoutDef>
 </file>
 
 <file path=ppt/diagrams/layout2.xml><?xml version="1.0" encoding="utf-8"?>
-<dgm:layoutDef xmlns:dgm="http://schemas.openxmlformats.org/drawingml/2006/diagram" uniqueId="urn:microsoft.com/office/officeart/2005/8/layout/hierarchy1"/>
+<dgm:layoutDef xmlns:dgm="http://schemas.openxmlformats.org/drawingml/2006/diagram" uniqueId="urn:microsoft.com/office/officeart/2005/8/layout/hierarchy1">
+  <dgm:title val="FreeP SmartArt"/>
+  <dgm:desc val="Deterministic FreeP SmartArt fixture"/>
+  <dgm:catLst/>
+  <dgm:sampData/>
+  <dgm:styleData/>
+  <dgm:clrData/>
+  <dgm:layoutNode name="root">
+    <dgm:varLst/>
+    <dgm:alg type="lin"/>
+    <dgm:shape type="rect">
+      <dgm:adjLst/>
+    </dgm:shape>
+    <dgm:presOf/>
+    <dgm:constrLst/>
+    <dgm:ruleLst/>
+  </dgm:layoutNode>
+</dgm:layoutDef>
 </file>
 
 <file path=ppt/diagrams/layout3.xml><?xml version="1.0" encoding="utf-8"?>
-<dgm:layoutDef xmlns:dgm="http://schemas.openxmlformats.org/drawingml/2006/diagram" uniqueId="urn:microsoft.com/office/officeart/2005/8/layout/hierarchy3"/>
+<dgm:layoutDef xmlns:dgm="http://schemas.openxmlformats.org/drawingml/2006/diagram" uniqueId="urn:microsoft.com/office/officeart/2005/8/layout/hierarchy3">
+  <dgm:title val="FreeP SmartArt"/>
+  <dgm:desc val="Deterministic FreeP SmartArt fixture"/>
+  <dgm:catLst/>
+  <dgm:sampData/>
+  <dgm:styleData/>
+  <dgm:clrData/>
+  <dgm:layoutNode name="root">
+    <dgm:varLst/>
+    <dgm:alg type="lin"/>
+    <dgm:shape type="rect">
+      <dgm:adjLst/>
+    </dgm:shape>
+    <dgm:presOf/>
+    <dgm:constrLst/>
+    <dgm:ruleLst/>
+  </dgm:layoutNode>
+</dgm:layoutDef>
 </file>
 
 <file path=ppt/diagrams/layout4.xml><?xml version="1.0" encoding="utf-8"?>
-<dgm:layoutDef xmlns:dgm="http://schemas.openxmlformats.org/drawingml/2006/diagram" uniqueId="urn:microsoft.com/office/officeart/2005/8/layout/cycle1"/>
+<dgm:layoutDef xmlns:dgm="http://schemas.openxmlformats.org/drawingml/2006/diagram" uniqueId="urn:microsoft.com/office/officeart/2005/8/layout/cycle1">
+  <dgm:title val="FreeP SmartArt"/>
+  <dgm:desc val="Deterministic FreeP SmartArt fixture"/>
+  <dgm:catLst/>
+  <dgm:sampData/>
+  <dgm:styleData/>
+  <dgm:clrData/>
+  <dgm:layoutNode name="root">
+    <dgm:varLst/>
+    <dgm:alg type="lin"/>
+    <dgm:shape type="rect">
+      <dgm:adjLst/>
+    </dgm:shape>
+    <dgm:presOf/>
+    <dgm:constrLst/>
+    <dgm:ruleLst/>
+  </dgm:layoutNode>
+</dgm:layoutDef>
 </file>
 
 <file path=ppt/diagrams/layout5.xml><?xml version="1.0" encoding="utf-8"?>
-<dgm:layoutDef xmlns:dgm="http://schemas.openxmlformats.org/drawingml/2006/diagram" uniqueId="urn:microsoft.com/office/officeart/2005/8/layout/list1"/>
+<dgm:layoutDef xmlns:dgm="http://schemas.openxmlformats.org/drawingml/2006/diagram" uniqueId="urn:microsoft.com/office/officeart/2005/8/layout/list1">
+  <dgm:title val="FreeP SmartArt"/>
+  <dgm:desc val="Deterministic FreeP SmartArt fixture"/>
+  <dgm:catLst/>
+  <dgm:sampData/>
+  <dgm:styleData/>
+  <dgm:clrData/>
+  <dgm:layoutNode name="root">
+    <dgm:varLst/>
+    <dgm:alg type="lin"/>
+    <dgm:shape type="rect">
+      <dgm:adjLst/>
+    </dgm:shape>
+    <dgm:presOf/>
+    <dgm:constrLst/>
+    <dgm:ruleLst/>
+  </dgm:layoutNode>
+</dgm:layoutDef>
 </file>
 
 <file path=ppt/diagrams/layout6.xml><?xml version="1.0" encoding="utf-8"?>
-<dgm:layoutDef xmlns:dgm="http://schemas.openxmlformats.org/drawingml/2006/diagram" uniqueId="urn:microsoft.com/office/officeart/2005/8/layout/groupedList"/>
+<dgm:layoutDef xmlns:dgm="http://schemas.openxmlformats.org/drawingml/2006/diagram" uniqueId="urn:microsoft.com/office/officeart/2005/8/layout/groupedList">
+  <dgm:title val="FreeP SmartArt"/>
+  <dgm:desc val="Deterministic FreeP SmartArt fixture"/>
+  <dgm:catLst/>
+  <dgm:sampData/>
+  <dgm:styleData/>
+  <dgm:clrData/>
+  <dgm:layoutNode name="root">
+    <dgm:varLst/>
+    <dgm:alg type="lin"/>
+    <dgm:shape type="rect">
+      <dgm:adjLst/>
+    </dgm:shape>
+    <dgm:presOf/>
+    <dgm:constrLst/>
+    <dgm:ruleLst/>
+  </dgm:layoutNode>
+</dgm:layoutDef>
 </file>
 
 <file path=ppt/diagrams/layout7.xml><?xml version="1.0" encoding="utf-8"?>
-<dgm:layoutDef xmlns:dgm="http://schemas.openxmlformats.org/drawingml/2006/diagram" uniqueId="urn:microsoft.com/office/officeart/2005/8/layout/relationship1"/>
+<dgm:layoutDef xmlns:dgm="http://schemas.openxmlformats.org/drawingml/2006/diagram" uniqueId="urn:microsoft.com/office/officeart/2005/8/layout/relationship1">
+  <dgm:title val="FreeP SmartArt"/>
+  <dgm:desc val="Deterministic FreeP SmartArt fixture"/>
+  <dgm:catLst/>
+  <dgm:sampData/>
+  <dgm:styleData/>
+  <dgm:clrData/>
+  <dgm:layoutNode name="root">
+    <dgm:varLst/>
+    <dgm:alg type="lin"/>
+    <dgm:shape type="rect">
+      <dgm:adjLst/>
+    </dgm:shape>
+    <dgm:presOf/>
+    <dgm:constrLst/>
+    <dgm:ruleLst/>
+  </dgm:layoutNode>
+</dgm:layoutDef>
 </file>
 
 <file path=ppt/diagrams/layout8.xml><?xml version="1.0" encoding="utf-8"?>
-<dgm:layoutDef xmlns:dgm="http://schemas.openxmlformats.org/drawingml/2006/diagram" uniqueId="urn:microsoft.com/office/officeart/2005/8/layout/gridMatrix"/>
+<dgm:layoutDef xmlns:dgm="http://schemas.openxmlformats.org/drawingml/2006/diagram" uniqueId="urn:microsoft.com/office/officeart/2005/8/layout/gridMatrix">
+  <dgm:title val="FreeP SmartArt"/>
+  <dgm:desc val="Deterministic FreeP SmartArt fixture"/>
+  <dgm:catLst/>
+  <dgm:sampData/>
+  <dgm:styleData/>
+  <dgm:clrData/>
+  <dgm:layoutNode name="root">
+    <dgm:varLst/>
+    <dgm:alg type="lin"/>
+    <dgm:shape type="rect">
+      <dgm:adjLst/>
+    </dgm:shape>
+    <dgm:presOf/>
+    <dgm:constrLst/>
+    <dgm:ruleLst/>
+  </dgm:layoutNode>
+</dgm:layoutDef>
 </file>
 
 <file path=ppt/diagrams/layout9.xml><?xml version="1.0" encoding="utf-8"?>
-<dgm:layoutDef xmlns:dgm="http://schemas.openxmlformats.org/drawingml/2006/diagram" uniqueId="urn:microsoft.com/office/officeart/2005/8/layout/increasingCircleProcess"/>
+<dgm:layoutDef xmlns:dgm="http://schemas.openxmlformats.org/drawingml/2006/diagram" uniqueId="urn:microsoft.com/office/officeart/2005/8/layout/increasingCircleProcess">
+  <dgm:title val="FreeP SmartArt"/>
+  <dgm:desc val="Deterministic FreeP SmartArt fixture"/>
+  <dgm:catLst/>
+  <dgm:sampData/>
+  <dgm:styleData/>
+  <dgm:clrData/>
+  <dgm:layoutNode name="root">
+    <dgm:varLst/>
+    <dgm:alg type="lin"/>
+    <dgm:shape type="rect">
+      <dgm:adjLst/>
+    </dgm:shape>
+    <dgm:presOf/>
+    <dgm:constrLst/>
+    <dgm:ruleLst/>
+  </dgm:layoutNode>
+</dgm:layoutDef>
 </file>
 
 <file path=ppt/diagrams/quickStyle1.xml><?xml version="1.0" encoding="utf-8"?>
-<dgm:styleDef xmlns:dgm="http://schemas.openxmlformats.org/drawingml/2006/diagram"/>
+<dgm:styleDef xmlns:dgm="http://schemas.openxmlformats.org/drawingml/2006/diagram" xmlns:a="http://schemas.openxmlformats.org/drawingml/2006/main">
+  <dgm:title val="FreeP SmartArt"/>
+  <dgm:desc val="Deterministic FreeP SmartArt style"/>
+  <dgm:catLst/>
+  <dgm:scene3d>
+    <a:camera prst="orthographicFront"/>
+    <a:lightRig rig="threePt" dir="t"/>
+  </dgm:scene3d>
+  <dgm:styleLbl name="node0">
+    <dgm:scene3d>
+      <a:camera prst="orthographicFront"/>
+      <a:lightRig rig="threePt" dir="t"/>
+    </dgm:scene3d>
+    <dgm:sp3d/>
+    <dgm:txPr/>
+    <dgm:style>
+      <a:lnRef idx="2"/>
+      <a:fillRef idx="1"/>
+      <a:effectRef idx="0"/>
+      <a:fontRef idx="minor"/>
+    </dgm:style>
+  </dgm:styleLbl>
+</dgm:styleDef>
 </file>
 
 <file path=ppt/diagrams/quickStyle10.xml><?xml version="1.0" encoding="utf-8"?>
-<dgm:styleDef xmlns:dgm="http://schemas.openxmlformats.org/drawingml/2006/diagram"/>
+<dgm:styleDef xmlns:dgm="http://schemas.openxmlformats.org/drawingml/2006/diagram" xmlns:a="http://schemas.openxmlformats.org/drawingml/2006/main">
+  <dgm:title val="FreeP SmartArt"/>
+  <dgm:desc val="Deterministic FreeP SmartArt style"/>
+  <dgm:catLst/>
+  <dgm:scene3d>
+    <a:camera prst="orthographicFront"/>
+    <a:lightRig rig="threePt" dir="t"/>
+  </dgm:scene3d>
+  <dgm:styleLbl name="node0">
+    <dgm:scene3d>
+      <a:camera prst="orthographicFront"/>
+      <a:lightRig rig="threePt" dir="t"/>
+    </dgm:scene3d>
+    <dgm:sp3d/>
+    <dgm:txPr/>
+    <dgm:style>
+      <a:lnRef idx="2"/>
+      <a:fillRef idx="1"/>
+      <a:effectRef idx="0"/>
+      <a:fontRef idx="minor"/>
+    </dgm:style>
+  </dgm:styleLbl>
+</dgm:styleDef>
 </file>
 
 <file path=ppt/diagrams/quickStyle2.xml><?xml version="1.0" encoding="utf-8"?>
-<dgm:styleDef xmlns:dgm="http://schemas.openxmlformats.org/drawingml/2006/diagram"/>
+<dgm:styleDef xmlns:dgm="http://schemas.openxmlformats.org/drawingml/2006/diagram" xmlns:a="http://schemas.openxmlformats.org/drawingml/2006/main">
+  <dgm:title val="FreeP SmartArt"/>
+  <dgm:desc val="Deterministic FreeP SmartArt style"/>
+  <dgm:catLst/>
+  <dgm:scene3d>
+    <a:camera prst="orthographicFront"/>
+    <a:lightRig rig="threePt" dir="t"/>
+  </dgm:scene3d>
+  <dgm:styleLbl name="node0">
+    <dgm:scene3d>
+      <a:camera prst="orthographicFront"/>
+      <a:lightRig rig="threePt" dir="t"/>
+    </dgm:scene3d>
+    <dgm:sp3d/>
+    <dgm:txPr/>
+    <dgm:style>
+      <a:lnRef idx="2"/>
+      <a:fillRef idx="1"/>
+      <a:effectRef idx="0"/>
+      <a:fontRef idx="minor"/>
+    </dgm:style>
+  </dgm:styleLbl>
+</dgm:styleDef>
 </file>
 
 <file path=ppt/diagrams/quickStyle3.xml><?xml version="1.0" encoding="utf-8"?>
-<dgm:styleDef xmlns:dgm="http://schemas.openxmlformats.org/drawingml/2006/diagram"/>
+<dgm:styleDef xmlns:dgm="http://schemas.openxmlformats.org/drawingml/2006/diagram" xmlns:a="http://schemas.openxmlformats.org/drawingml/2006/main">
+  <dgm:title val="FreeP SmartArt"/>
+  <dgm:desc val="Deterministic FreeP SmartArt style"/>
+  <dgm:catLst/>
+  <dgm:scene3d>
+    <a:camera prst="orthographicFront"/>
+    <a:lightRig rig="threePt" dir="t"/>
+  </dgm:scene3d>
+  <dgm:styleLbl name="node0">
+    <dgm:scene3d>
+      <a:camera prst="orthographicFront"/>
+      <a:lightRig rig="threePt" dir="t"/>
+    </dgm:scene3d>
+    <dgm:sp3d/>
+    <dgm:txPr/>
+    <dgm:style>
+      <a:lnRef idx="2"/>
+      <a:fillRef idx="1"/>
+      <a:effectRef idx="0"/>
+      <a:fontRef idx="minor"/>
+    </dgm:style>
+  </dgm:styleLbl>
+</dgm:styleDef>
 </file>
 
 <file path=ppt/diagrams/quickStyle4.xml><?xml version="1.0" encoding="utf-8"?>
-<dgm:styleDef xmlns:dgm="http://schemas.openxmlformats.org/drawingml/2006/diagram"/>
+<dgm:styleDef xmlns:dgm="http://schemas.openxmlformats.org/drawingml/2006/diagram" xmlns:a="http://schemas.openxmlformats.org/drawingml/2006/main">
+  <dgm:title val="FreeP SmartArt"/>
+  <dgm:desc val="Deterministic FreeP SmartArt style"/>
+  <dgm:catLst/>
+  <dgm:scene3d>
+    <a:camera prst="orthographicFront"/>
+    <a:lightRig rig="threePt" dir="t"/>
+  </dgm:scene3d>
+  <dgm:styleLbl name="node0">
+    <dgm:scene3d>
+      <a:camera prst="orthographicFront"/>
+      <a:lightRig rig="threePt" dir="t"/>
+    </dgm:scene3d>
+    <dgm:sp3d/>
+    <dgm:txPr/>
+    <dgm:style>
+      <a:lnRef idx="2"/>
+      <a:fillRef idx="1"/>
+      <a:effectRef idx="0"/>
+      <a:fontRef idx="minor"/>
+    </dgm:style>
+  </dgm:styleLbl>
+</dgm:styleDef>
 </file>
 
 <file path=ppt/diagrams/quickStyle5.xml><?xml version="1.0" encoding="utf-8"?>
-<dgm:styleDef xmlns:dgm="http://schemas.openxmlformats.org/drawingml/2006/diagram"/>
+<dgm:styleDef xmlns:dgm="http://schemas.openxmlformats.org/drawingml/2006/diagram" xmlns:a="http://schemas.openxmlformats.org/drawingml/2006/main">
+  <dgm:title val="FreeP SmartArt"/>
+  <dgm:desc val="Deterministic FreeP SmartArt style"/>
+  <dgm:catLst/>
+  <dgm:scene3d>
+    <a:camera prst="orthographicFront"/>
+    <a:lightRig rig="threePt" dir="t"/>
+  </dgm:scene3d>
+  <dgm:styleLbl name="node0">
+    <dgm:scene3d>
+      <a:camera prst="orthographicFront"/>
+      <a:lightRig rig="threePt" dir="t"/>
+    </dgm:scene3d>
+    <dgm:sp3d/>
+    <dgm:txPr/>
+    <dgm:style>
+      <a:lnRef idx="2"/>
+      <a:fillRef idx="1"/>
+      <a:effectRef idx="0"/>
+      <a:fontRef idx="minor"/>
+    </dgm:style>
+  </dgm:styleLbl>
+</dgm:styleDef>
 </file>
 
 <file path=ppt/diagrams/quickStyle6.xml><?xml version="1.0" encoding="utf-8"?>
-<dgm:styleDef xmlns:dgm="http://schemas.openxmlformats.org/drawingml/2006/diagram"/>
+<dgm:styleDef xmlns:dgm="http://schemas.openxmlformats.org/drawingml/2006/diagram" xmlns:a="http://schemas.openxmlformats.org/drawingml/2006/main">
+  <dgm:title val="FreeP SmartArt"/>
+  <dgm:desc val="Deterministic FreeP SmartArt style"/>
+  <dgm:catLst/>
+  <dgm:scene3d>
+    <a:camera prst="orthographicFront"/>
+    <a:lightRig rig="threePt" dir="t"/>
+  </dgm:scene3d>
+  <dgm:styleLbl name="node0">
+    <dgm:scene3d>
+      <a:camera prst="orthographicFront"/>
+      <a:lightRig rig="threePt" dir="t"/>
+    </dgm:scene3d>
+    <dgm:sp3d/>
+    <dgm:txPr/>
+    <dgm:style>
+      <a:lnRef idx="2"/>
+      <a:fillRef idx="1"/>
+      <a:effectRef idx="0"/>
+      <a:fontRef idx="minor"/>
+    </dgm:style>
+  </dgm:styleLbl>
+</dgm:styleDef>
 </file>
 
 <file path=ppt/diagrams/quickStyle7.xml><?xml version="1.0" encoding="utf-8"?>
-<dgm:styleDef xmlns:dgm="http://schemas.openxmlformats.org/drawingml/2006/diagram"/>
+<dgm:styleDef xmlns:dgm="http://schemas.openxmlformats.org/drawingml/2006/diagram" xmlns:a="http://schemas.openxmlformats.org/drawingml/2006/main">
+  <dgm:title val="FreeP SmartArt"/>
+  <dgm:desc val="Deterministic FreeP SmartArt style"/>
+  <dgm:catLst/>
+  <dgm:scene3d>
+    <a:camera prst="orthographicFront"/>
+    <a:lightRig rig="threePt" dir="t"/>
+  </dgm:scene3d>
+  <dgm:styleLbl name="node0">
+    <dgm:scene3d>
+      <a:camera prst="orthographicFront"/>
+      <a:lightRig rig="threePt" dir="t"/>
+    </dgm:scene3d>
+    <dgm:sp3d/>
+    <dgm:txPr/>
+    <dgm:style>
+      <a:lnRef idx="2"/>
+      <a:fillRef idx="1"/>
+      <a:effectRef idx="0"/>
+      <a:fontRef idx="minor"/>
+    </dgm:style>
+  </dgm:styleLbl>
+</dgm:styleDef>
 </file>
 
 <file path=ppt/diagrams/quickStyle8.xml><?xml version="1.0" encoding="utf-8"?>
-<dgm:styleDef xmlns:dgm="http://schemas.openxmlformats.org/drawingml/2006/diagram"/>
+<dgm:styleDef xmlns:dgm="http://schemas.openxmlformats.org/drawingml/2006/diagram" xmlns:a="http://schemas.openxmlformats.org/drawingml/2006/main">
+  <dgm:title val="FreeP SmartArt"/>
+  <dgm:desc val="Deterministic FreeP SmartArt style"/>
+  <dgm:catLst/>
+  <dgm:scene3d>
+    <a:camera prst="orthographicFront"/>
+    <a:lightRig rig="threePt" dir="t"/>
+  </dgm:scene3d>
+  <dgm:styleLbl name="node0">
+    <dgm:scene3d>
+      <a:camera prst="orthographicFront"/>
+      <a:lightRig rig="threePt" dir="t"/>
+    </dgm:scene3d>
+    <dgm:sp3d/>
+    <dgm:txPr/>
+    <dgm:style>
+      <a:lnRef idx="2"/>
+      <a:fillRef idx="1"/>
+      <a:effectRef idx="0"/>
+      <a:fontRef idx="minor"/>
+    </dgm:style>
+  </dgm:styleLbl>
+</dgm:styleDef>
 </file>
 
 <file path=ppt/diagrams/quickStyle9.xml><?xml version="1.0" encoding="utf-8"?>
-<dgm:styleDef xmlns:dgm="http://schemas.openxmlformats.org/drawingml/2006/diagram"/>
+<dgm:styleDef xmlns:dgm="http://schemas.openxmlformats.org/drawingml/2006/diagram" xmlns:a="http://schemas.openxmlformats.org/drawingml/2006/main">
+  <dgm:title val="FreeP SmartArt"/>
+  <dgm:desc val="Deterministic FreeP SmartArt style"/>
+  <dgm:catLst/>
+  <dgm:scene3d>
+    <a:camera prst="orthographicFront"/>
+    <a:lightRig rig="threePt" dir="t"/>
+  </dgm:scene3d>
+  <dgm:styleLbl name="node0">
+    <dgm:scene3d>
+      <a:camera prst="orthographicFront"/>
+      <a:lightRig rig="threePt" dir="t"/>
+    </dgm:scene3d>
+    <dgm:sp3d/>
+    <dgm:txPr/>
+    <dgm:style>
+      <a:lnRef idx="2"/>
+      <a:fillRef idx="1"/>
+      <a:effectRef idx="0"/>
+      <a:fontRef idx="minor"/>
+    </dgm:style>
+  </dgm:styleLbl>
+</dgm:styleDef>
 </file>
 
 <file path=ppt/slideLayouts/slideLayout1.xml><?xml version="1.0" encoding="utf-8"?>
-<p:sldLayout xmlns:p="http://schemas.openxmlformats.org/presentationml/2006/main" xmlns:a="http://schemas.openxmlformats.org/drawingml/2006/main" xmlns:r="http://schemas.openxmlformats.org/officeDocument/2006/relationships" type="blank">
+<p:sldLayout xmlns:p="http://schemas.openxmlformats.org/presentationml/2006/main" xmlns:a="http://schemas.openxmlformats.org/drawingml/2006/main" xmlns:r="http://schemas.openxmlformats.org/officeDocument/2006/relationships" type="blank" showMasterSp="1" showMasterPhAnim="1">
   <p:cSld>
     <p:spTree>
       <p:nvGrpSpPr>
@@ -1953,6 +2671,9 @@
       </p:grpSpPr>
     </p:spTree>
   </p:cSld>
+  <p:clrMapOvr>
+    <a:masterClrMapping/>
+  </p:clrMapOvr>
 </p:sldLayout>
 </file>
 
@@ -1976,6 +2697,26 @@
     </p:spTree>
   </p:cSld>
   <p:clrMap bg1="lt1" tx1="dk1" bg2="lt2" tx2="dk2" accent1="accent1" accent2="accent2" accent3="accent3" accent4="accent4" accent5="accent5" accent6="accent6" hlink="hlink" folHlink="folHlink"/>
+  <p:sldLayoutIdLst>
+    <p:sldLayoutId id="2147483649" r:id="rId2"/>
+  </p:sldLayoutIdLst>
+  <p:txStyles>
+    <p:titleStyle>
+      <a:lvl1pPr>
+        <a:defRPr/>
+      </a:lvl1pPr>
+    </p:titleStyle>
+    <p:bodyStyle>
+      <a:lvl1pPr>
+        <a:defRPr/>
+      </a:lvl1pPr>
+    </p:bodyStyle>
+    <p:otherStyle>
+      <a:lvl1pPr>
+        <a:defRPr/>
+      </a:lvl1pPr>
+    </p:otherStyle>
+  </p:txStyles>
 </p:sldMaster>
 </file>
 
@@ -2673,12 +3414,70 @@
     <a:fontScheme name="Office">
       <a:majorFont>
         <a:latin typeface="Calibri Light"/>
+        <a:ea typeface=""/>
+        <a:cs typeface=""/>
       </a:majorFont>
       <a:minorFont>
         <a:latin typeface="Calibri"/>
+        <a:ea typeface=""/>
+        <a:cs typeface=""/>
       </a:minorFont>
     </a:fontScheme>
-    <a:fmtScheme name="Office"/>
+    <a:fmtScheme name="Office">
+      <a:fillStyleLst>
+        <a:solidFill>
+          <a:schemeClr val="phClr"/>
+        </a:solidFill>
+        <a:solidFill>
+          <a:schemeClr val="phClr"/>
+        </a:solidFill>
+        <a:solidFill>
+          <a:schemeClr val="phClr"/>
+        </a:solidFill>
+      </a:fillStyleLst>
+      <a:lnStyleLst>
+        <a:ln w="12700">
+          <a:solidFill>
+            <a:schemeClr val="phClr"/>
+          </a:solidFill>
+          <a:prstDash val="solid"/>
+        </a:ln>
+        <a:ln w="19050">
+          <a:solidFill>
+            <a:schemeClr val="phClr"/>
+          </a:solidFill>
+          <a:prstDash val="solid"/>
+        </a:ln>
+        <a:ln w="25400">
+          <a:solidFill>
+            <a:schemeClr val="phClr"/>
+          </a:solidFill>
+          <a:prstDash val="solid"/>
+        </a:ln>
+      </a:lnStyleLst>
+      <a:effectStyleLst>
+        <a:effectStyle>
+          <a:effectLst/>
+        </a:effectStyle>
+        <a:effectStyle>
+          <a:effectLst/>
+        </a:effectStyle>
+        <a:effectStyle>
+          <a:effectLst/>
+        </a:effectStyle>
+      </a:effectStyleLst>
+      <a:bgFillStyleLst>
+        <a:solidFill>
+          <a:schemeClr val="phClr"/>
+        </a:solidFill>
+        <a:solidFill>
+          <a:schemeClr val="phClr"/>
+        </a:solidFill>
+        <a:solidFill>
+          <a:schemeClr val="phClr"/>
+        </a:solidFill>
+      </a:bgFillStyleLst>
+    </a:fmtScheme>
   </a:themeElements>
 </a:theme>
 </file>
</xml_diff>